<commit_message>
## [2026-06-14] 試著修正iPhone 上有時無法EditDialog Save
</commit_message>
<xml_diff>
--- a/Discussion/vocus01/邁向NBL.pptx
+++ b/Discussion/vocus01/邁向NBL.pptx
@@ -8,6 +8,12 @@
     <p:sldId id="256" r:id="rId2"/>
     <p:sldId id="257" r:id="rId3"/>
     <p:sldId id="258" r:id="rId4"/>
+    <p:sldId id="259" r:id="rId5"/>
+    <p:sldId id="260" r:id="rId6"/>
+    <p:sldId id="261" r:id="rId7"/>
+    <p:sldId id="262" r:id="rId8"/>
+    <p:sldId id="263" r:id="rId9"/>
+    <p:sldId id="264" r:id="rId10"/>
   </p:sldIdLst>
   <p:sldSz cx="12192000" cy="6858000"/>
   <p:notesSz cx="6858000" cy="9144000"/>
@@ -117,7 +123,7 @@
 <file path=ppt/revisionInfo.xml><?xml version="1.0" encoding="utf-8"?>
 <p1510:revInfo xmlns:a="http://schemas.openxmlformats.org/drawingml/2006/main" xmlns:r="http://schemas.openxmlformats.org/officeDocument/2006/relationships" xmlns:p1510="http://schemas.microsoft.com/office/powerpoint/2015/10/main">
   <p1510:revLst>
-    <p1510:client id="{BCBEB3AD-DBA8-496B-B2CB-9B930FF21D9E}" v="5" dt="2026-06-08T05:49:36.668"/>
+    <p1510:client id="{BCBEB3AD-DBA8-496B-B2CB-9B930FF21D9E}" v="59" dt="2026-06-13T07:05:44.978"/>
   </p1510:revLst>
 </p1510:revInfo>
 </file>
@@ -126,8 +132,8 @@
 <pc:chgInfo xmlns:a="http://schemas.openxmlformats.org/drawingml/2006/main" xmlns:r="http://schemas.openxmlformats.org/officeDocument/2006/relationships" xmlns:ac="http://schemas.microsoft.com/office/drawing/2013/main/command" xmlns:pc="http://schemas.microsoft.com/office/powerpoint/2013/main/command">
   <pc:docChgLst>
     <pc:chgData name="Young-Chung Hsue" userId="0d39fb11249e9e67" providerId="LiveId" clId="{A170C4A5-6498-4AC0-A24E-EBB8A3864606}"/>
-    <pc:docChg chg="custSel addSld modSld">
-      <pc:chgData name="Young-Chung Hsue" userId="0d39fb11249e9e67" providerId="LiveId" clId="{A170C4A5-6498-4AC0-A24E-EBB8A3864606}" dt="2026-06-10T05:16:37.305" v="81" actId="478"/>
+    <pc:docChg chg="undo custSel addSld modSld">
+      <pc:chgData name="Young-Chung Hsue" userId="0d39fb11249e9e67" providerId="LiveId" clId="{A170C4A5-6498-4AC0-A24E-EBB8A3864606}" dt="2026-06-13T07:05:44.977" v="518"/>
       <pc:docMkLst>
         <pc:docMk/>
       </pc:docMkLst>
@@ -202,28 +208,390 @@
           </ac:cxnSpMkLst>
         </pc:cxnChg>
       </pc:sldChg>
-      <pc:sldChg chg="delSp new mod">
-        <pc:chgData name="Young-Chung Hsue" userId="0d39fb11249e9e67" providerId="LiveId" clId="{A170C4A5-6498-4AC0-A24E-EBB8A3864606}" dt="2026-06-10T05:16:37.305" v="81" actId="478"/>
+      <pc:sldChg chg="addSp delSp modSp new mod">
+        <pc:chgData name="Young-Chung Hsue" userId="0d39fb11249e9e67" providerId="LiveId" clId="{A170C4A5-6498-4AC0-A24E-EBB8A3864606}" dt="2026-06-12T05:09:57.414" v="171" actId="14100"/>
         <pc:sldMkLst>
           <pc:docMk/>
           <pc:sldMk cId="2439407990" sldId="258"/>
         </pc:sldMkLst>
-        <pc:spChg chg="del">
-          <ac:chgData name="Young-Chung Hsue" userId="0d39fb11249e9e67" providerId="LiveId" clId="{A170C4A5-6498-4AC0-A24E-EBB8A3864606}" dt="2026-06-10T05:16:37.305" v="81" actId="478"/>
+        <pc:spChg chg="add mod">
+          <ac:chgData name="Young-Chung Hsue" userId="0d39fb11249e9e67" providerId="LiveId" clId="{A170C4A5-6498-4AC0-A24E-EBB8A3864606}" dt="2026-06-12T05:09:00.846" v="145" actId="1076"/>
           <ac:spMkLst>
             <pc:docMk/>
             <pc:sldMk cId="2439407990" sldId="258"/>
-            <ac:spMk id="2" creationId="{9ACEB9B1-3C60-8CAF-1405-F24FD01CE62B}"/>
+            <ac:spMk id="4" creationId="{A58323FD-732B-8F84-4A07-D246CA5667C0}"/>
+          </ac:spMkLst>
+        </pc:spChg>
+        <pc:spChg chg="add mod">
+          <ac:chgData name="Young-Chung Hsue" userId="0d39fb11249e9e67" providerId="LiveId" clId="{A170C4A5-6498-4AC0-A24E-EBB8A3864606}" dt="2026-06-12T05:09:31.140" v="168" actId="20577"/>
+          <ac:spMkLst>
+            <pc:docMk/>
+            <pc:sldMk cId="2439407990" sldId="258"/>
+            <ac:spMk id="7" creationId="{52208066-8DE1-9055-CE10-82BFF9B211D4}"/>
+          </ac:spMkLst>
+        </pc:spChg>
+        <pc:picChg chg="add mod">
+          <ac:chgData name="Young-Chung Hsue" userId="0d39fb11249e9e67" providerId="LiveId" clId="{A170C4A5-6498-4AC0-A24E-EBB8A3864606}" dt="2026-06-12T05:09:57.414" v="171" actId="14100"/>
+          <ac:picMkLst>
+            <pc:docMk/>
+            <pc:sldMk cId="2439407990" sldId="258"/>
+            <ac:picMk id="3" creationId="{5CE988D3-B22A-FCB1-7FD2-7871E3107122}"/>
+          </ac:picMkLst>
+        </pc:picChg>
+        <pc:picChg chg="add mod">
+          <ac:chgData name="Young-Chung Hsue" userId="0d39fb11249e9e67" providerId="LiveId" clId="{A170C4A5-6498-4AC0-A24E-EBB8A3864606}" dt="2026-06-12T05:08:51.840" v="144" actId="14100"/>
+          <ac:picMkLst>
+            <pc:docMk/>
+            <pc:sldMk cId="2439407990" sldId="258"/>
+            <ac:picMk id="6" creationId="{F14CC56F-43B5-EF8D-9EC5-9DDC5EC0A87F}"/>
+          </ac:picMkLst>
+        </pc:picChg>
+      </pc:sldChg>
+      <pc:sldChg chg="addSp delSp modSp new mod addAnim delAnim modAnim">
+        <pc:chgData name="Young-Chung Hsue" userId="0d39fb11249e9e67" providerId="LiveId" clId="{A170C4A5-6498-4AC0-A24E-EBB8A3864606}" dt="2026-06-13T04:43:02.521" v="240" actId="1036"/>
+        <pc:sldMkLst>
+          <pc:docMk/>
+          <pc:sldMk cId="1274500183" sldId="259"/>
+        </pc:sldMkLst>
+        <pc:spChg chg="del">
+          <ac:chgData name="Young-Chung Hsue" userId="0d39fb11249e9e67" providerId="LiveId" clId="{A170C4A5-6498-4AC0-A24E-EBB8A3864606}" dt="2026-06-13T04:32:09.826" v="173" actId="478"/>
+          <ac:spMkLst>
+            <pc:docMk/>
+            <pc:sldMk cId="1274500183" sldId="259"/>
+            <ac:spMk id="2" creationId="{EDD4A3BF-3414-8534-03B4-2EEBC8A328C0}"/>
           </ac:spMkLst>
         </pc:spChg>
         <pc:spChg chg="del">
-          <ac:chgData name="Young-Chung Hsue" userId="0d39fb11249e9e67" providerId="LiveId" clId="{A170C4A5-6498-4AC0-A24E-EBB8A3864606}" dt="2026-06-10T05:16:37.305" v="81" actId="478"/>
+          <ac:chgData name="Young-Chung Hsue" userId="0d39fb11249e9e67" providerId="LiveId" clId="{A170C4A5-6498-4AC0-A24E-EBB8A3864606}" dt="2026-06-13T04:32:09.826" v="173" actId="478"/>
           <ac:spMkLst>
             <pc:docMk/>
-            <pc:sldMk cId="2439407990" sldId="258"/>
-            <ac:spMk id="3" creationId="{2F4A5193-082E-33A5-6471-1C2A29DFDD60}"/>
+            <pc:sldMk cId="1274500183" sldId="259"/>
+            <ac:spMk id="3" creationId="{F3869FD4-62DC-6DCE-C50D-9BE5652E61E9}"/>
           </ac:spMkLst>
         </pc:spChg>
+        <pc:grpChg chg="add mod">
+          <ac:chgData name="Young-Chung Hsue" userId="0d39fb11249e9e67" providerId="LiveId" clId="{A170C4A5-6498-4AC0-A24E-EBB8A3864606}" dt="2026-06-13T04:43:02.521" v="240" actId="1036"/>
+          <ac:grpSpMkLst>
+            <pc:docMk/>
+            <pc:sldMk cId="1274500183" sldId="259"/>
+            <ac:grpSpMk id="9" creationId="{41245C16-E4F8-639D-1FEE-53B8C4EB206C}"/>
+          </ac:grpSpMkLst>
+        </pc:grpChg>
+        <pc:picChg chg="add mod">
+          <ac:chgData name="Young-Chung Hsue" userId="0d39fb11249e9e67" providerId="LiveId" clId="{A170C4A5-6498-4AC0-A24E-EBB8A3864606}" dt="2026-06-13T04:42:40.351" v="218" actId="14100"/>
+          <ac:picMkLst>
+            <pc:docMk/>
+            <pc:sldMk cId="1274500183" sldId="259"/>
+            <ac:picMk id="5" creationId="{4D2F7C8A-D39C-9FBF-B2DA-90A12B19FD23}"/>
+          </ac:picMkLst>
+        </pc:picChg>
+        <pc:picChg chg="add mod">
+          <ac:chgData name="Young-Chung Hsue" userId="0d39fb11249e9e67" providerId="LiveId" clId="{A170C4A5-6498-4AC0-A24E-EBB8A3864606}" dt="2026-06-13T04:35:02.081" v="182" actId="164"/>
+          <ac:picMkLst>
+            <pc:docMk/>
+            <pc:sldMk cId="1274500183" sldId="259"/>
+            <ac:picMk id="7" creationId="{C11CB596-7BEA-8B1A-566F-0F5C7F269026}"/>
+          </ac:picMkLst>
+        </pc:picChg>
+        <pc:picChg chg="add mod">
+          <ac:chgData name="Young-Chung Hsue" userId="0d39fb11249e9e67" providerId="LiveId" clId="{A170C4A5-6498-4AC0-A24E-EBB8A3864606}" dt="2026-06-13T04:35:02.081" v="182" actId="164"/>
+          <ac:picMkLst>
+            <pc:docMk/>
+            <pc:sldMk cId="1274500183" sldId="259"/>
+            <ac:picMk id="8" creationId="{E4F999DF-E23A-0A6E-1332-39CA965AF288}"/>
+          </ac:picMkLst>
+        </pc:picChg>
+        <pc:cxnChg chg="add mod">
+          <ac:chgData name="Young-Chung Hsue" userId="0d39fb11249e9e67" providerId="LiveId" clId="{A170C4A5-6498-4AC0-A24E-EBB8A3864606}" dt="2026-06-13T04:43:02.521" v="240" actId="1036"/>
+          <ac:cxnSpMkLst>
+            <pc:docMk/>
+            <pc:sldMk cId="1274500183" sldId="259"/>
+            <ac:cxnSpMk id="11" creationId="{21A49949-BDE5-E037-C296-F7CA55AEF715}"/>
+          </ac:cxnSpMkLst>
+        </pc:cxnChg>
+        <pc:cxnChg chg="add mod">
+          <ac:chgData name="Young-Chung Hsue" userId="0d39fb11249e9e67" providerId="LiveId" clId="{A170C4A5-6498-4AC0-A24E-EBB8A3864606}" dt="2026-06-13T04:43:02.521" v="240" actId="1036"/>
+          <ac:cxnSpMkLst>
+            <pc:docMk/>
+            <pc:sldMk cId="1274500183" sldId="259"/>
+            <ac:cxnSpMk id="12" creationId="{56E4E32F-04F9-DAE8-1B92-47D988565620}"/>
+          </ac:cxnSpMkLst>
+        </pc:cxnChg>
+        <pc:cxnChg chg="add mod">
+          <ac:chgData name="Young-Chung Hsue" userId="0d39fb11249e9e67" providerId="LiveId" clId="{A170C4A5-6498-4AC0-A24E-EBB8A3864606}" dt="2026-06-13T04:36:47.571" v="193" actId="693"/>
+          <ac:cxnSpMkLst>
+            <pc:docMk/>
+            <pc:sldMk cId="1274500183" sldId="259"/>
+            <ac:cxnSpMk id="14" creationId="{B20B3032-18E3-1FEF-7B59-B4650E194BC1}"/>
+          </ac:cxnSpMkLst>
+        </pc:cxnChg>
+        <pc:cxnChg chg="add mod">
+          <ac:chgData name="Young-Chung Hsue" userId="0d39fb11249e9e67" providerId="LiveId" clId="{A170C4A5-6498-4AC0-A24E-EBB8A3864606}" dt="2026-06-13T04:43:02.521" v="240" actId="1036"/>
+          <ac:cxnSpMkLst>
+            <pc:docMk/>
+            <pc:sldMk cId="1274500183" sldId="259"/>
+            <ac:cxnSpMk id="15" creationId="{CB631A60-AB3A-B63B-7A12-6739246F7750}"/>
+          </ac:cxnSpMkLst>
+        </pc:cxnChg>
+      </pc:sldChg>
+      <pc:sldChg chg="addSp delSp modSp new mod delAnim modAnim">
+        <pc:chgData name="Young-Chung Hsue" userId="0d39fb11249e9e67" providerId="LiveId" clId="{A170C4A5-6498-4AC0-A24E-EBB8A3864606}" dt="2026-06-13T04:48:47.241" v="269"/>
+        <pc:sldMkLst>
+          <pc:docMk/>
+          <pc:sldMk cId="2160912273" sldId="260"/>
+        </pc:sldMkLst>
+        <pc:spChg chg="del">
+          <ac:chgData name="Young-Chung Hsue" userId="0d39fb11249e9e67" providerId="LiveId" clId="{A170C4A5-6498-4AC0-A24E-EBB8A3864606}" dt="2026-06-13T04:41:03.999" v="213" actId="478"/>
+          <ac:spMkLst>
+            <pc:docMk/>
+            <pc:sldMk cId="2160912273" sldId="260"/>
+            <ac:spMk id="2" creationId="{AECCE0BD-7DDF-DBFB-DED6-A64337EB4329}"/>
+          </ac:spMkLst>
+        </pc:spChg>
+        <pc:spChg chg="del">
+          <ac:chgData name="Young-Chung Hsue" userId="0d39fb11249e9e67" providerId="LiveId" clId="{A170C4A5-6498-4AC0-A24E-EBB8A3864606}" dt="2026-06-13T04:41:03.999" v="213" actId="478"/>
+          <ac:spMkLst>
+            <pc:docMk/>
+            <pc:sldMk cId="2160912273" sldId="260"/>
+            <ac:spMk id="3" creationId="{951D6284-8CAA-8864-2EDF-8BAF95705CFE}"/>
+          </ac:spMkLst>
+        </pc:spChg>
+        <pc:grpChg chg="add mod">
+          <ac:chgData name="Young-Chung Hsue" userId="0d39fb11249e9e67" providerId="LiveId" clId="{A170C4A5-6498-4AC0-A24E-EBB8A3864606}" dt="2026-06-13T04:43:16.123" v="242"/>
+          <ac:grpSpMkLst>
+            <pc:docMk/>
+            <pc:sldMk cId="2160912273" sldId="260"/>
+            <ac:grpSpMk id="8" creationId="{94F8514F-6E38-F499-F46E-A74CB895F8A3}"/>
+          </ac:grpSpMkLst>
+        </pc:grpChg>
+        <pc:picChg chg="add del">
+          <ac:chgData name="Young-Chung Hsue" userId="0d39fb11249e9e67" providerId="LiveId" clId="{A170C4A5-6498-4AC0-A24E-EBB8A3864606}" dt="2026-06-13T04:42:12.730" v="215" actId="478"/>
+          <ac:picMkLst>
+            <pc:docMk/>
+            <pc:sldMk cId="2160912273" sldId="260"/>
+            <ac:picMk id="5" creationId="{BA520301-C7AF-4203-7D0F-2E1AAB822808}"/>
+          </ac:picMkLst>
+        </pc:picChg>
+        <pc:picChg chg="add mod">
+          <ac:chgData name="Young-Chung Hsue" userId="0d39fb11249e9e67" providerId="LiveId" clId="{A170C4A5-6498-4AC0-A24E-EBB8A3864606}" dt="2026-06-13T04:43:31.620" v="248" actId="1035"/>
+          <ac:picMkLst>
+            <pc:docMk/>
+            <pc:sldMk cId="2160912273" sldId="260"/>
+            <ac:picMk id="7" creationId="{B6FC4D14-A389-B148-61A8-35E35BD19DBB}"/>
+          </ac:picMkLst>
+        </pc:picChg>
+        <pc:picChg chg="mod">
+          <ac:chgData name="Young-Chung Hsue" userId="0d39fb11249e9e67" providerId="LiveId" clId="{A170C4A5-6498-4AC0-A24E-EBB8A3864606}" dt="2026-06-13T04:43:16.123" v="242"/>
+          <ac:picMkLst>
+            <pc:docMk/>
+            <pc:sldMk cId="2160912273" sldId="260"/>
+            <ac:picMk id="9" creationId="{F91A057D-4812-AE58-685E-33D3401410C8}"/>
+          </ac:picMkLst>
+        </pc:picChg>
+        <pc:picChg chg="mod">
+          <ac:chgData name="Young-Chung Hsue" userId="0d39fb11249e9e67" providerId="LiveId" clId="{A170C4A5-6498-4AC0-A24E-EBB8A3864606}" dt="2026-06-13T04:43:16.123" v="242"/>
+          <ac:picMkLst>
+            <pc:docMk/>
+            <pc:sldMk cId="2160912273" sldId="260"/>
+            <ac:picMk id="10" creationId="{41676DB9-34CA-1814-29FB-5EC25CF9E2FB}"/>
+          </ac:picMkLst>
+        </pc:picChg>
+        <pc:cxnChg chg="add del mod">
+          <ac:chgData name="Young-Chung Hsue" userId="0d39fb11249e9e67" providerId="LiveId" clId="{A170C4A5-6498-4AC0-A24E-EBB8A3864606}" dt="2026-06-13T04:44:49.500" v="249" actId="478"/>
+          <ac:cxnSpMkLst>
+            <pc:docMk/>
+            <pc:sldMk cId="2160912273" sldId="260"/>
+            <ac:cxnSpMk id="11" creationId="{DF667943-4D98-EC36-5451-41BBF15855D2}"/>
+          </ac:cxnSpMkLst>
+        </pc:cxnChg>
+        <pc:cxnChg chg="add del mod">
+          <ac:chgData name="Young-Chung Hsue" userId="0d39fb11249e9e67" providerId="LiveId" clId="{A170C4A5-6498-4AC0-A24E-EBB8A3864606}" dt="2026-06-13T04:44:49.500" v="249" actId="478"/>
+          <ac:cxnSpMkLst>
+            <pc:docMk/>
+            <pc:sldMk cId="2160912273" sldId="260"/>
+            <ac:cxnSpMk id="12" creationId="{E925B30D-A1D8-DEF7-FA47-1B62366455FD}"/>
+          </ac:cxnSpMkLst>
+        </pc:cxnChg>
+        <pc:cxnChg chg="add mod">
+          <ac:chgData name="Young-Chung Hsue" userId="0d39fb11249e9e67" providerId="LiveId" clId="{A170C4A5-6498-4AC0-A24E-EBB8A3864606}" dt="2026-06-13T04:44:58.511" v="251" actId="14100"/>
+          <ac:cxnSpMkLst>
+            <pc:docMk/>
+            <pc:sldMk cId="2160912273" sldId="260"/>
+            <ac:cxnSpMk id="13" creationId="{62BCAF6D-4407-BC98-058B-F73C0D2E18DD}"/>
+          </ac:cxnSpMkLst>
+        </pc:cxnChg>
+        <pc:cxnChg chg="add mod">
+          <ac:chgData name="Young-Chung Hsue" userId="0d39fb11249e9e67" providerId="LiveId" clId="{A170C4A5-6498-4AC0-A24E-EBB8A3864606}" dt="2026-06-13T04:48:19.954" v="266" actId="1076"/>
+          <ac:cxnSpMkLst>
+            <pc:docMk/>
+            <pc:sldMk cId="2160912273" sldId="260"/>
+            <ac:cxnSpMk id="19" creationId="{C519280F-6C5C-1FED-6B78-5F97D7FB00B6}"/>
+          </ac:cxnSpMkLst>
+        </pc:cxnChg>
+      </pc:sldChg>
+      <pc:sldChg chg="addSp delSp modSp new mod">
+        <pc:chgData name="Young-Chung Hsue" userId="0d39fb11249e9e67" providerId="LiveId" clId="{A170C4A5-6498-4AC0-A24E-EBB8A3864606}" dt="2026-06-13T05:10:36.046" v="273"/>
+        <pc:sldMkLst>
+          <pc:docMk/>
+          <pc:sldMk cId="3408930596" sldId="261"/>
+        </pc:sldMkLst>
+        <pc:spChg chg="del">
+          <ac:chgData name="Young-Chung Hsue" userId="0d39fb11249e9e67" providerId="LiveId" clId="{A170C4A5-6498-4AC0-A24E-EBB8A3864606}" dt="2026-06-13T05:10:34.107" v="271" actId="478"/>
+          <ac:spMkLst>
+            <pc:docMk/>
+            <pc:sldMk cId="3408930596" sldId="261"/>
+            <ac:spMk id="2" creationId="{D1D4CDDE-7644-5A6B-0914-6B6F516C8D3F}"/>
+          </ac:spMkLst>
+        </pc:spChg>
+        <pc:spChg chg="del">
+          <ac:chgData name="Young-Chung Hsue" userId="0d39fb11249e9e67" providerId="LiveId" clId="{A170C4A5-6498-4AC0-A24E-EBB8A3864606}" dt="2026-06-13T05:10:34.107" v="271" actId="478"/>
+          <ac:spMkLst>
+            <pc:docMk/>
+            <pc:sldMk cId="3408930596" sldId="261"/>
+            <ac:spMk id="3" creationId="{ED7C17A3-FCCC-C23B-67A9-C5E121CFEBEA}"/>
+          </ac:spMkLst>
+        </pc:spChg>
+        <pc:picChg chg="add mod">
+          <ac:chgData name="Young-Chung Hsue" userId="0d39fb11249e9e67" providerId="LiveId" clId="{A170C4A5-6498-4AC0-A24E-EBB8A3864606}" dt="2026-06-13T05:10:36.046" v="273"/>
+          <ac:picMkLst>
+            <pc:docMk/>
+            <pc:sldMk cId="3408930596" sldId="261"/>
+            <ac:picMk id="5" creationId="{FB4874DA-BD76-C36F-7C40-9C16C5A4E03D}"/>
+          </ac:picMkLst>
+        </pc:picChg>
+      </pc:sldChg>
+      <pc:sldChg chg="modSp new mod modAnim">
+        <pc:chgData name="Young-Chung Hsue" userId="0d39fb11249e9e67" providerId="LiveId" clId="{A170C4A5-6498-4AC0-A24E-EBB8A3864606}" dt="2026-06-13T06:36:57.644" v="457" actId="1035"/>
+        <pc:sldMkLst>
+          <pc:docMk/>
+          <pc:sldMk cId="848532407" sldId="262"/>
+        </pc:sldMkLst>
+        <pc:spChg chg="mod">
+          <ac:chgData name="Young-Chung Hsue" userId="0d39fb11249e9e67" providerId="LiveId" clId="{A170C4A5-6498-4AC0-A24E-EBB8A3864606}" dt="2026-06-13T06:34:35.576" v="454" actId="20577"/>
+          <ac:spMkLst>
+            <pc:docMk/>
+            <pc:sldMk cId="848532407" sldId="262"/>
+            <ac:spMk id="2" creationId="{E51B1235-3ABB-DA3F-014D-656267C12433}"/>
+          </ac:spMkLst>
+        </pc:spChg>
+        <pc:spChg chg="mod">
+          <ac:chgData name="Young-Chung Hsue" userId="0d39fb11249e9e67" providerId="LiveId" clId="{A170C4A5-6498-4AC0-A24E-EBB8A3864606}" dt="2026-06-13T06:36:57.644" v="457" actId="1035"/>
+          <ac:spMkLst>
+            <pc:docMk/>
+            <pc:sldMk cId="848532407" sldId="262"/>
+            <ac:spMk id="3" creationId="{076BDB3D-53BF-8CEE-0AD1-E2EF46AE8F73}"/>
+          </ac:spMkLst>
+        </pc:spChg>
+      </pc:sldChg>
+      <pc:sldChg chg="addSp delSp modSp add mod delAnim modAnim">
+        <pc:chgData name="Young-Chung Hsue" userId="0d39fb11249e9e67" providerId="LiveId" clId="{A170C4A5-6498-4AC0-A24E-EBB8A3864606}" dt="2026-06-13T07:05:44.977" v="518"/>
+        <pc:sldMkLst>
+          <pc:docMk/>
+          <pc:sldMk cId="779573481" sldId="263"/>
+        </pc:sldMkLst>
+        <pc:spChg chg="add del">
+          <ac:chgData name="Young-Chung Hsue" userId="0d39fb11249e9e67" providerId="LiveId" clId="{A170C4A5-6498-4AC0-A24E-EBB8A3864606}" dt="2026-06-13T07:01:56.190" v="509" actId="11529"/>
+          <ac:spMkLst>
+            <pc:docMk/>
+            <pc:sldMk cId="779573481" sldId="263"/>
+            <ac:spMk id="23" creationId="{99118187-5AB1-8959-8759-241C28D1A50E}"/>
+          </ac:spMkLst>
+        </pc:spChg>
+        <pc:spChg chg="add del">
+          <ac:chgData name="Young-Chung Hsue" userId="0d39fb11249e9e67" providerId="LiveId" clId="{A170C4A5-6498-4AC0-A24E-EBB8A3864606}" dt="2026-06-13T07:02:35.242" v="511" actId="11529"/>
+          <ac:spMkLst>
+            <pc:docMk/>
+            <pc:sldMk cId="779573481" sldId="263"/>
+            <ac:spMk id="24" creationId="{95024E03-852C-8F4F-02EF-008841AFA898}"/>
+          </ac:spMkLst>
+        </pc:spChg>
+        <pc:spChg chg="add mod">
+          <ac:chgData name="Young-Chung Hsue" userId="0d39fb11249e9e67" providerId="LiveId" clId="{A170C4A5-6498-4AC0-A24E-EBB8A3864606}" dt="2026-06-13T07:04:00.203" v="515" actId="206"/>
+          <ac:spMkLst>
+            <pc:docMk/>
+            <pc:sldMk cId="779573481" sldId="263"/>
+            <ac:spMk id="25" creationId="{A5432C9D-9B21-B9B2-742F-C8BC1296F3FB}"/>
+          </ac:spMkLst>
+        </pc:spChg>
+        <pc:picChg chg="mod">
+          <ac:chgData name="Young-Chung Hsue" userId="0d39fb11249e9e67" providerId="LiveId" clId="{A170C4A5-6498-4AC0-A24E-EBB8A3864606}" dt="2026-06-13T06:59:48.354" v="503" actId="1036"/>
+          <ac:picMkLst>
+            <pc:docMk/>
+            <pc:sldMk cId="779573481" sldId="263"/>
+            <ac:picMk id="7" creationId="{D5A01124-C611-5166-0539-3AC761C67E8E}"/>
+          </ac:picMkLst>
+        </pc:picChg>
+        <pc:cxnChg chg="add mod">
+          <ac:chgData name="Young-Chung Hsue" userId="0d39fb11249e9e67" providerId="LiveId" clId="{A170C4A5-6498-4AC0-A24E-EBB8A3864606}" dt="2026-06-13T06:46:56.622" v="462" actId="1582"/>
+          <ac:cxnSpMkLst>
+            <pc:docMk/>
+            <pc:sldMk cId="779573481" sldId="263"/>
+            <ac:cxnSpMk id="3" creationId="{05708A91-25FA-55D8-4712-440F7E5429F9}"/>
+          </ac:cxnSpMkLst>
+        </pc:cxnChg>
+        <pc:cxnChg chg="add mod">
+          <ac:chgData name="Young-Chung Hsue" userId="0d39fb11249e9e67" providerId="LiveId" clId="{A170C4A5-6498-4AC0-A24E-EBB8A3864606}" dt="2026-06-13T06:57:28.990" v="491" actId="208"/>
+          <ac:cxnSpMkLst>
+            <pc:docMk/>
+            <pc:sldMk cId="779573481" sldId="263"/>
+            <ac:cxnSpMk id="4" creationId="{C010FA95-64EE-5DFE-4AA2-7CAA316884B8}"/>
+          </ac:cxnSpMkLst>
+        </pc:cxnChg>
+        <pc:cxnChg chg="add mod">
+          <ac:chgData name="Young-Chung Hsue" userId="0d39fb11249e9e67" providerId="LiveId" clId="{A170C4A5-6498-4AC0-A24E-EBB8A3864606}" dt="2026-06-13T06:51:18.263" v="475" actId="1076"/>
+          <ac:cxnSpMkLst>
+            <pc:docMk/>
+            <pc:sldMk cId="779573481" sldId="263"/>
+            <ac:cxnSpMk id="5" creationId="{5B180585-321A-EBA6-7D93-7CC4DEEE27CB}"/>
+          </ac:cxnSpMkLst>
+        </pc:cxnChg>
+        <pc:cxnChg chg="add mod">
+          <ac:chgData name="Young-Chung Hsue" userId="0d39fb11249e9e67" providerId="LiveId" clId="{A170C4A5-6498-4AC0-A24E-EBB8A3864606}" dt="2026-06-13T06:57:24.908" v="490" actId="208"/>
+          <ac:cxnSpMkLst>
+            <pc:docMk/>
+            <pc:sldMk cId="779573481" sldId="263"/>
+            <ac:cxnSpMk id="6" creationId="{33E99434-9AAB-59F7-CA4C-6FAA4B28F248}"/>
+          </ac:cxnSpMkLst>
+        </pc:cxnChg>
+        <pc:cxnChg chg="del">
+          <ac:chgData name="Young-Chung Hsue" userId="0d39fb11249e9e67" providerId="LiveId" clId="{A170C4A5-6498-4AC0-A24E-EBB8A3864606}" dt="2026-06-13T06:44:18.334" v="459" actId="478"/>
+          <ac:cxnSpMkLst>
+            <pc:docMk/>
+            <pc:sldMk cId="779573481" sldId="263"/>
+            <ac:cxnSpMk id="13" creationId="{F56CF335-179E-9CE2-B57F-03F034BDA4C8}"/>
+          </ac:cxnSpMkLst>
+        </pc:cxnChg>
+      </pc:sldChg>
+      <pc:sldChg chg="addSp delSp modSp new mod">
+        <pc:chgData name="Young-Chung Hsue" userId="0d39fb11249e9e67" providerId="LiveId" clId="{A170C4A5-6498-4AC0-A24E-EBB8A3864606}" dt="2026-06-13T07:00:06.468" v="507" actId="1036"/>
+        <pc:sldMkLst>
+          <pc:docMk/>
+          <pc:sldMk cId="3917660026" sldId="264"/>
+        </pc:sldMkLst>
+        <pc:spChg chg="del">
+          <ac:chgData name="Young-Chung Hsue" userId="0d39fb11249e9e67" providerId="LiveId" clId="{A170C4A5-6498-4AC0-A24E-EBB8A3864606}" dt="2026-06-13T06:55:16.121" v="486" actId="478"/>
+          <ac:spMkLst>
+            <pc:docMk/>
+            <pc:sldMk cId="3917660026" sldId="264"/>
+            <ac:spMk id="2" creationId="{56F253C3-3A4C-4749-1990-A347C4803E06}"/>
+          </ac:spMkLst>
+        </pc:spChg>
+        <pc:spChg chg="del">
+          <ac:chgData name="Young-Chung Hsue" userId="0d39fb11249e9e67" providerId="LiveId" clId="{A170C4A5-6498-4AC0-A24E-EBB8A3864606}" dt="2026-06-13T06:55:16.121" v="486" actId="478"/>
+          <ac:spMkLst>
+            <pc:docMk/>
+            <pc:sldMk cId="3917660026" sldId="264"/>
+            <ac:spMk id="3" creationId="{643CDD4A-8860-EFB6-5AAC-AEBC63B2D61B}"/>
+          </ac:spMkLst>
+        </pc:spChg>
+        <pc:picChg chg="add mod">
+          <ac:chgData name="Young-Chung Hsue" userId="0d39fb11249e9e67" providerId="LiveId" clId="{A170C4A5-6498-4AC0-A24E-EBB8A3864606}" dt="2026-06-13T07:00:06.468" v="507" actId="1036"/>
+          <ac:picMkLst>
+            <pc:docMk/>
+            <pc:sldMk cId="3917660026" sldId="264"/>
+            <ac:picMk id="5" creationId="{585EA3A8-789A-B9CC-B4C1-880969259A4F}"/>
+          </ac:picMkLst>
+        </pc:picChg>
       </pc:sldChg>
     </pc:docChg>
   </pc:docChgLst>
@@ -377,7 +745,7 @@
           <a:p>
             <a:fld id="{F4D4ABA2-7608-43F0-88F1-EB9CC2A63409}" type="datetimeFigureOut">
               <a:rPr lang="zh-TW" altLang="en-US" smtClean="0"/>
-              <a:t>2026/6/10</a:t>
+              <a:t>2026/6/13</a:t>
             </a:fld>
             <a:endParaRPr lang="zh-TW" altLang="en-US"/>
           </a:p>
@@ -575,7 +943,7 @@
           <a:p>
             <a:fld id="{F4D4ABA2-7608-43F0-88F1-EB9CC2A63409}" type="datetimeFigureOut">
               <a:rPr lang="zh-TW" altLang="en-US" smtClean="0"/>
-              <a:t>2026/6/10</a:t>
+              <a:t>2026/6/13</a:t>
             </a:fld>
             <a:endParaRPr lang="zh-TW" altLang="en-US"/>
           </a:p>
@@ -783,7 +1151,7 @@
           <a:p>
             <a:fld id="{F4D4ABA2-7608-43F0-88F1-EB9CC2A63409}" type="datetimeFigureOut">
               <a:rPr lang="zh-TW" altLang="en-US" smtClean="0"/>
-              <a:t>2026/6/10</a:t>
+              <a:t>2026/6/13</a:t>
             </a:fld>
             <a:endParaRPr lang="zh-TW" altLang="en-US"/>
           </a:p>
@@ -981,7 +1349,7 @@
           <a:p>
             <a:fld id="{F4D4ABA2-7608-43F0-88F1-EB9CC2A63409}" type="datetimeFigureOut">
               <a:rPr lang="zh-TW" altLang="en-US" smtClean="0"/>
-              <a:t>2026/6/10</a:t>
+              <a:t>2026/6/13</a:t>
             </a:fld>
             <a:endParaRPr lang="zh-TW" altLang="en-US"/>
           </a:p>
@@ -1256,7 +1624,7 @@
           <a:p>
             <a:fld id="{F4D4ABA2-7608-43F0-88F1-EB9CC2A63409}" type="datetimeFigureOut">
               <a:rPr lang="zh-TW" altLang="en-US" smtClean="0"/>
-              <a:t>2026/6/10</a:t>
+              <a:t>2026/6/13</a:t>
             </a:fld>
             <a:endParaRPr lang="zh-TW" altLang="en-US"/>
           </a:p>
@@ -1521,7 +1889,7 @@
           <a:p>
             <a:fld id="{F4D4ABA2-7608-43F0-88F1-EB9CC2A63409}" type="datetimeFigureOut">
               <a:rPr lang="zh-TW" altLang="en-US" smtClean="0"/>
-              <a:t>2026/6/10</a:t>
+              <a:t>2026/6/13</a:t>
             </a:fld>
             <a:endParaRPr lang="zh-TW" altLang="en-US"/>
           </a:p>
@@ -1933,7 +2301,7 @@
           <a:p>
             <a:fld id="{F4D4ABA2-7608-43F0-88F1-EB9CC2A63409}" type="datetimeFigureOut">
               <a:rPr lang="zh-TW" altLang="en-US" smtClean="0"/>
-              <a:t>2026/6/10</a:t>
+              <a:t>2026/6/13</a:t>
             </a:fld>
             <a:endParaRPr lang="zh-TW" altLang="en-US"/>
           </a:p>
@@ -2074,7 +2442,7 @@
           <a:p>
             <a:fld id="{F4D4ABA2-7608-43F0-88F1-EB9CC2A63409}" type="datetimeFigureOut">
               <a:rPr lang="zh-TW" altLang="en-US" smtClean="0"/>
-              <a:t>2026/6/10</a:t>
+              <a:t>2026/6/13</a:t>
             </a:fld>
             <a:endParaRPr lang="zh-TW" altLang="en-US"/>
           </a:p>
@@ -2187,7 +2555,7 @@
           <a:p>
             <a:fld id="{F4D4ABA2-7608-43F0-88F1-EB9CC2A63409}" type="datetimeFigureOut">
               <a:rPr lang="zh-TW" altLang="en-US" smtClean="0"/>
-              <a:t>2026/6/10</a:t>
+              <a:t>2026/6/13</a:t>
             </a:fld>
             <a:endParaRPr lang="zh-TW" altLang="en-US"/>
           </a:p>
@@ -2498,7 +2866,7 @@
           <a:p>
             <a:fld id="{F4D4ABA2-7608-43F0-88F1-EB9CC2A63409}" type="datetimeFigureOut">
               <a:rPr lang="zh-TW" altLang="en-US" smtClean="0"/>
-              <a:t>2026/6/10</a:t>
+              <a:t>2026/6/13</a:t>
             </a:fld>
             <a:endParaRPr lang="zh-TW" altLang="en-US"/>
           </a:p>
@@ -2786,7 +3154,7 @@
           <a:p>
             <a:fld id="{F4D4ABA2-7608-43F0-88F1-EB9CC2A63409}" type="datetimeFigureOut">
               <a:rPr lang="zh-TW" altLang="en-US" smtClean="0"/>
-              <a:t>2026/6/10</a:t>
+              <a:t>2026/6/13</a:t>
             </a:fld>
             <a:endParaRPr lang="zh-TW" altLang="en-US"/>
           </a:p>
@@ -3027,7 +3395,7 @@
           <a:p>
             <a:fld id="{F4D4ABA2-7608-43F0-88F1-EB9CC2A63409}" type="datetimeFigureOut">
               <a:rPr lang="zh-TW" altLang="en-US" smtClean="0"/>
-              <a:t>2026/6/10</a:t>
+              <a:t>2026/6/13</a:t>
             </a:fld>
             <a:endParaRPr lang="zh-TW" altLang="en-US"/>
           </a:p>
@@ -4200,10 +4568,2872 @@
           <a:chExt cx="0" cy="0"/>
         </a:xfrm>
       </p:grpSpPr>
+      <p:pic>
+        <p:nvPicPr>
+          <p:cNvPr id="3" name="圖片 2">
+            <a:extLst>
+              <a:ext uri="{FF2B5EF4-FFF2-40B4-BE49-F238E27FC236}">
+                <a16:creationId xmlns:a16="http://schemas.microsoft.com/office/drawing/2014/main" id="{5CE988D3-B22A-FCB1-7FD2-7871E3107122}"/>
+              </a:ext>
+            </a:extLst>
+          </p:cNvPr>
+          <p:cNvPicPr>
+            <a:picLocks noChangeAspect="1"/>
+          </p:cNvPicPr>
+          <p:nvPr/>
+        </p:nvPicPr>
+        <p:blipFill>
+          <a:blip r:embed="rId2"/>
+          <a:stretch>
+            <a:fillRect/>
+          </a:stretch>
+        </p:blipFill>
+        <p:spPr>
+          <a:xfrm>
+            <a:off x="1086426" y="920234"/>
+            <a:ext cx="5009573" cy="5009573"/>
+          </a:xfrm>
+          <a:prstGeom prst="rect">
+            <a:avLst/>
+          </a:prstGeom>
+        </p:spPr>
+      </p:pic>
+      <p:sp>
+        <p:nvSpPr>
+          <p:cNvPr id="4" name="文字方塊 3">
+            <a:extLst>
+              <a:ext uri="{FF2B5EF4-FFF2-40B4-BE49-F238E27FC236}">
+                <a16:creationId xmlns:a16="http://schemas.microsoft.com/office/drawing/2014/main" id="{A58323FD-732B-8F84-4A07-D246CA5667C0}"/>
+              </a:ext>
+            </a:extLst>
+          </p:cNvPr>
+          <p:cNvSpPr txBox="1"/>
+          <p:nvPr/>
+        </p:nvSpPr>
+        <p:spPr>
+          <a:xfrm>
+            <a:off x="2306825" y="5568433"/>
+            <a:ext cx="1811971" cy="369332"/>
+          </a:xfrm>
+          <a:prstGeom prst="rect">
+            <a:avLst/>
+          </a:prstGeom>
+          <a:noFill/>
+        </p:spPr>
+        <p:txBody>
+          <a:bodyPr wrap="none" rtlCol="0">
+            <a:spAutoFit/>
+          </a:bodyPr>
+          <a:lstStyle/>
+          <a:p>
+            <a:r>
+              <a:rPr lang="en-US" altLang="zh-TW" dirty="0" err="1"/>
+              <a:t>NonBlockingLife</a:t>
+            </a:r>
+            <a:endParaRPr lang="zh-TW" altLang="en-US" dirty="0"/>
+          </a:p>
+        </p:txBody>
+      </p:sp>
+      <p:pic>
+        <p:nvPicPr>
+          <p:cNvPr id="6" name="圖片 5">
+            <a:extLst>
+              <a:ext uri="{FF2B5EF4-FFF2-40B4-BE49-F238E27FC236}">
+                <a16:creationId xmlns:a16="http://schemas.microsoft.com/office/drawing/2014/main" id="{F14CC56F-43B5-EF8D-9EC5-9DDC5EC0A87F}"/>
+              </a:ext>
+            </a:extLst>
+          </p:cNvPr>
+          <p:cNvPicPr>
+            <a:picLocks noChangeAspect="1"/>
+          </p:cNvPicPr>
+          <p:nvPr/>
+        </p:nvPicPr>
+        <p:blipFill>
+          <a:blip r:embed="rId3"/>
+          <a:stretch>
+            <a:fillRect/>
+          </a:stretch>
+        </p:blipFill>
+        <p:spPr>
+          <a:xfrm>
+            <a:off x="5915024" y="1038224"/>
+            <a:ext cx="4714875" cy="4714875"/>
+          </a:xfrm>
+          <a:prstGeom prst="rect">
+            <a:avLst/>
+          </a:prstGeom>
+        </p:spPr>
+      </p:pic>
+      <p:sp>
+        <p:nvSpPr>
+          <p:cNvPr id="7" name="文字方塊 6">
+            <a:extLst>
+              <a:ext uri="{FF2B5EF4-FFF2-40B4-BE49-F238E27FC236}">
+                <a16:creationId xmlns:a16="http://schemas.microsoft.com/office/drawing/2014/main" id="{52208066-8DE1-9055-CE10-82BFF9B211D4}"/>
+              </a:ext>
+            </a:extLst>
+          </p:cNvPr>
+          <p:cNvSpPr txBox="1"/>
+          <p:nvPr/>
+        </p:nvSpPr>
+        <p:spPr>
+          <a:xfrm>
+            <a:off x="7450325" y="5568433"/>
+            <a:ext cx="2304029" cy="369332"/>
+          </a:xfrm>
+          <a:prstGeom prst="rect">
+            <a:avLst/>
+          </a:prstGeom>
+          <a:noFill/>
+        </p:spPr>
+        <p:txBody>
+          <a:bodyPr wrap="none" rtlCol="0">
+            <a:spAutoFit/>
+          </a:bodyPr>
+          <a:lstStyle/>
+          <a:p>
+            <a:r>
+              <a:rPr lang="en-US" altLang="zh-TW" dirty="0"/>
+              <a:t>Example on Stately.ai</a:t>
+            </a:r>
+            <a:endParaRPr lang="zh-TW" altLang="en-US" dirty="0"/>
+          </a:p>
+        </p:txBody>
+      </p:sp>
     </p:spTree>
     <p:extLst>
       <p:ext uri="{BB962C8B-B14F-4D97-AF65-F5344CB8AC3E}">
         <p14:creationId xmlns:p14="http://schemas.microsoft.com/office/powerpoint/2010/main" val="2439407990"/>
+      </p:ext>
+    </p:extLst>
+  </p:cSld>
+  <p:clrMapOvr>
+    <a:masterClrMapping/>
+  </p:clrMapOvr>
+</p:sld>
+</file>
+
+<file path=ppt/slides/slide4.xml><?xml version="1.0" encoding="utf-8"?>
+<p:sld xmlns:a="http://schemas.openxmlformats.org/drawingml/2006/main" xmlns:r="http://schemas.openxmlformats.org/officeDocument/2006/relationships" xmlns:p="http://schemas.openxmlformats.org/presentationml/2006/main">
+  <p:cSld>
+    <p:spTree>
+      <p:nvGrpSpPr>
+        <p:cNvPr id="1" name=""/>
+        <p:cNvGrpSpPr/>
+        <p:nvPr/>
+      </p:nvGrpSpPr>
+      <p:grpSpPr>
+        <a:xfrm>
+          <a:off x="0" y="0"/>
+          <a:ext cx="0" cy="0"/>
+          <a:chOff x="0" y="0"/>
+          <a:chExt cx="0" cy="0"/>
+        </a:xfrm>
+      </p:grpSpPr>
+      <p:pic>
+        <p:nvPicPr>
+          <p:cNvPr id="5" name="圖片 4">
+            <a:extLst>
+              <a:ext uri="{FF2B5EF4-FFF2-40B4-BE49-F238E27FC236}">
+                <a16:creationId xmlns:a16="http://schemas.microsoft.com/office/drawing/2014/main" id="{4D2F7C8A-D39C-9FBF-B2DA-90A12B19FD23}"/>
+              </a:ext>
+            </a:extLst>
+          </p:cNvPr>
+          <p:cNvPicPr>
+            <a:picLocks noChangeAspect="1"/>
+          </p:cNvPicPr>
+          <p:nvPr/>
+        </p:nvPicPr>
+        <p:blipFill>
+          <a:blip r:embed="rId2">
+            <a:extLst>
+              <a:ext uri="{28A0092B-C50C-407E-A947-70E740481C1C}">
+                <a14:useLocalDpi xmlns:a14="http://schemas.microsoft.com/office/drawing/2010/main" val="0"/>
+              </a:ext>
+            </a:extLst>
+          </a:blip>
+          <a:stretch>
+            <a:fillRect/>
+          </a:stretch>
+        </p:blipFill>
+        <p:spPr>
+          <a:xfrm>
+            <a:off x="1481946" y="236769"/>
+            <a:ext cx="9140658" cy="6446133"/>
+          </a:xfrm>
+          <a:prstGeom prst="rect">
+            <a:avLst/>
+          </a:prstGeom>
+        </p:spPr>
+      </p:pic>
+      <p:grpSp>
+        <p:nvGrpSpPr>
+          <p:cNvPr id="9" name="群組 8">
+            <a:extLst>
+              <a:ext uri="{FF2B5EF4-FFF2-40B4-BE49-F238E27FC236}">
+                <a16:creationId xmlns:a16="http://schemas.microsoft.com/office/drawing/2014/main" id="{41245C16-E4F8-639D-1FEE-53B8C4EB206C}"/>
+              </a:ext>
+            </a:extLst>
+          </p:cNvPr>
+          <p:cNvGrpSpPr/>
+          <p:nvPr/>
+        </p:nvGrpSpPr>
+        <p:grpSpPr>
+          <a:xfrm>
+            <a:off x="4505325" y="262028"/>
+            <a:ext cx="2971800" cy="1076325"/>
+            <a:chOff x="4505325" y="466311"/>
+            <a:chExt cx="2971800" cy="1076325"/>
+          </a:xfrm>
+        </p:grpSpPr>
+        <p:pic>
+          <p:nvPicPr>
+            <p:cNvPr id="7" name="圖形 6">
+              <a:extLst>
+                <a:ext uri="{FF2B5EF4-FFF2-40B4-BE49-F238E27FC236}">
+                  <a16:creationId xmlns:a16="http://schemas.microsoft.com/office/drawing/2014/main" id="{C11CB596-7BEA-8B1A-566F-0F5C7F269026}"/>
+                </a:ext>
+              </a:extLst>
+            </p:cNvPr>
+            <p:cNvPicPr>
+              <a:picLocks noChangeAspect="1"/>
+            </p:cNvPicPr>
+            <p:nvPr/>
+          </p:nvPicPr>
+          <p:blipFill>
+            <a:blip>
+              <a:extLst>
+                <a:ext uri="{96DAC541-7B7A-43D3-8B79-37D633B846F1}">
+                  <asvg:svgBlip xmlns:asvg="http://schemas.microsoft.com/office/drawing/2016/SVG/main" r:embed="rId3"/>
+                </a:ext>
+              </a:extLst>
+            </a:blip>
+            <a:stretch>
+              <a:fillRect/>
+            </a:stretch>
+          </p:blipFill>
+          <p:spPr>
+            <a:xfrm>
+              <a:off x="4505325" y="466311"/>
+              <a:ext cx="1076325" cy="1076325"/>
+            </a:xfrm>
+            <a:prstGeom prst="rect">
+              <a:avLst/>
+            </a:prstGeom>
+          </p:spPr>
+        </p:pic>
+        <p:pic>
+          <p:nvPicPr>
+            <p:cNvPr id="8" name="圖形 7">
+              <a:extLst>
+                <a:ext uri="{FF2B5EF4-FFF2-40B4-BE49-F238E27FC236}">
+                  <a16:creationId xmlns:a16="http://schemas.microsoft.com/office/drawing/2014/main" id="{E4F999DF-E23A-0A6E-1332-39CA965AF288}"/>
+                </a:ext>
+              </a:extLst>
+            </p:cNvPr>
+            <p:cNvPicPr>
+              <a:picLocks noChangeAspect="1"/>
+            </p:cNvPicPr>
+            <p:nvPr/>
+          </p:nvPicPr>
+          <p:blipFill>
+            <a:blip>
+              <a:extLst>
+                <a:ext uri="{96DAC541-7B7A-43D3-8B79-37D633B846F1}">
+                  <asvg:svgBlip xmlns:asvg="http://schemas.microsoft.com/office/drawing/2016/SVG/main" r:embed="rId3"/>
+                </a:ext>
+              </a:extLst>
+            </a:blip>
+            <a:stretch>
+              <a:fillRect/>
+            </a:stretch>
+          </p:blipFill>
+          <p:spPr>
+            <a:xfrm>
+              <a:off x="6400800" y="466311"/>
+              <a:ext cx="1076325" cy="1076325"/>
+            </a:xfrm>
+            <a:prstGeom prst="rect">
+              <a:avLst/>
+            </a:prstGeom>
+          </p:spPr>
+        </p:pic>
+      </p:grpSp>
+      <p:cxnSp>
+        <p:nvCxnSpPr>
+          <p:cNvPr id="11" name="直線接點 10">
+            <a:extLst>
+              <a:ext uri="{FF2B5EF4-FFF2-40B4-BE49-F238E27FC236}">
+                <a16:creationId xmlns:a16="http://schemas.microsoft.com/office/drawing/2014/main" id="{21A49949-BDE5-E037-C296-F7CA55AEF715}"/>
+              </a:ext>
+            </a:extLst>
+          </p:cNvPr>
+          <p:cNvCxnSpPr/>
+          <p:nvPr/>
+        </p:nvCxnSpPr>
+        <p:spPr>
+          <a:xfrm>
+            <a:off x="5061527" y="1412081"/>
+            <a:ext cx="0" cy="3749963"/>
+          </a:xfrm>
+          <a:prstGeom prst="line">
+            <a:avLst/>
+          </a:prstGeom>
+          <a:ln w="76200">
+            <a:solidFill>
+              <a:srgbClr val="FFC000"/>
+            </a:solidFill>
+          </a:ln>
+        </p:spPr>
+        <p:style>
+          <a:lnRef idx="2">
+            <a:schemeClr val="accent4"/>
+          </a:lnRef>
+          <a:fillRef idx="0">
+            <a:schemeClr val="accent4"/>
+          </a:fillRef>
+          <a:effectRef idx="1">
+            <a:schemeClr val="accent4"/>
+          </a:effectRef>
+          <a:fontRef idx="minor">
+            <a:schemeClr val="tx1"/>
+          </a:fontRef>
+        </p:style>
+      </p:cxnSp>
+      <p:cxnSp>
+        <p:nvCxnSpPr>
+          <p:cNvPr id="12" name="直線接點 11">
+            <a:extLst>
+              <a:ext uri="{FF2B5EF4-FFF2-40B4-BE49-F238E27FC236}">
+                <a16:creationId xmlns:a16="http://schemas.microsoft.com/office/drawing/2014/main" id="{56E4E32F-04F9-DAE8-1B92-47D988565620}"/>
+              </a:ext>
+            </a:extLst>
+          </p:cNvPr>
+          <p:cNvCxnSpPr/>
+          <p:nvPr/>
+        </p:nvCxnSpPr>
+        <p:spPr>
+          <a:xfrm>
+            <a:off x="6959600" y="1412081"/>
+            <a:ext cx="0" cy="3749963"/>
+          </a:xfrm>
+          <a:prstGeom prst="line">
+            <a:avLst/>
+          </a:prstGeom>
+          <a:ln w="76200">
+            <a:solidFill>
+              <a:srgbClr val="FFC000"/>
+            </a:solidFill>
+          </a:ln>
+        </p:spPr>
+        <p:style>
+          <a:lnRef idx="2">
+            <a:schemeClr val="accent4"/>
+          </a:lnRef>
+          <a:fillRef idx="0">
+            <a:schemeClr val="accent4"/>
+          </a:fillRef>
+          <a:effectRef idx="1">
+            <a:schemeClr val="accent4"/>
+          </a:effectRef>
+          <a:fontRef idx="minor">
+            <a:schemeClr val="tx1"/>
+          </a:fontRef>
+        </p:style>
+      </p:cxnSp>
+      <p:cxnSp>
+        <p:nvCxnSpPr>
+          <p:cNvPr id="14" name="直線接點 13">
+            <a:extLst>
+              <a:ext uri="{FF2B5EF4-FFF2-40B4-BE49-F238E27FC236}">
+                <a16:creationId xmlns:a16="http://schemas.microsoft.com/office/drawing/2014/main" id="{B20B3032-18E3-1FEF-7B59-B4650E194BC1}"/>
+              </a:ext>
+            </a:extLst>
+          </p:cNvPr>
+          <p:cNvCxnSpPr/>
+          <p:nvPr/>
+        </p:nvCxnSpPr>
+        <p:spPr>
+          <a:xfrm>
+            <a:off x="1894888" y="2447636"/>
+            <a:ext cx="5254057" cy="0"/>
+          </a:xfrm>
+          <a:prstGeom prst="line">
+            <a:avLst/>
+          </a:prstGeom>
+          <a:ln w="76200">
+            <a:solidFill>
+              <a:srgbClr val="0070C0"/>
+            </a:solidFill>
+            <a:prstDash val="dash"/>
+          </a:ln>
+        </p:spPr>
+        <p:style>
+          <a:lnRef idx="2">
+            <a:schemeClr val="accent1"/>
+          </a:lnRef>
+          <a:fillRef idx="0">
+            <a:schemeClr val="accent1"/>
+          </a:fillRef>
+          <a:effectRef idx="1">
+            <a:schemeClr val="accent1"/>
+          </a:effectRef>
+          <a:fontRef idx="minor">
+            <a:schemeClr val="tx1"/>
+          </a:fontRef>
+        </p:style>
+      </p:cxnSp>
+      <p:cxnSp>
+        <p:nvCxnSpPr>
+          <p:cNvPr id="15" name="直線接點 14">
+            <a:extLst>
+              <a:ext uri="{FF2B5EF4-FFF2-40B4-BE49-F238E27FC236}">
+                <a16:creationId xmlns:a16="http://schemas.microsoft.com/office/drawing/2014/main" id="{CB631A60-AB3A-B63B-7A12-6739246F7750}"/>
+              </a:ext>
+            </a:extLst>
+          </p:cNvPr>
+          <p:cNvCxnSpPr>
+            <a:cxnSpLocks/>
+          </p:cNvCxnSpPr>
+          <p:nvPr/>
+        </p:nvCxnSpPr>
+        <p:spPr>
+          <a:xfrm>
+            <a:off x="5061527" y="2331101"/>
+            <a:ext cx="1898073" cy="0"/>
+          </a:xfrm>
+          <a:prstGeom prst="line">
+            <a:avLst/>
+          </a:prstGeom>
+          <a:ln w="76200">
+            <a:solidFill>
+              <a:srgbClr val="0070C0"/>
+            </a:solidFill>
+            <a:prstDash val="dash"/>
+          </a:ln>
+        </p:spPr>
+        <p:style>
+          <a:lnRef idx="2">
+            <a:schemeClr val="accent1"/>
+          </a:lnRef>
+          <a:fillRef idx="0">
+            <a:schemeClr val="accent1"/>
+          </a:fillRef>
+          <a:effectRef idx="1">
+            <a:schemeClr val="accent1"/>
+          </a:effectRef>
+          <a:fontRef idx="minor">
+            <a:schemeClr val="tx1"/>
+          </a:fontRef>
+        </p:style>
+      </p:cxnSp>
+    </p:spTree>
+    <p:extLst>
+      <p:ext uri="{BB962C8B-B14F-4D97-AF65-F5344CB8AC3E}">
+        <p14:creationId xmlns:p14="http://schemas.microsoft.com/office/powerpoint/2010/main" val="1274500183"/>
+      </p:ext>
+    </p:extLst>
+  </p:cSld>
+  <p:clrMapOvr>
+    <a:masterClrMapping/>
+  </p:clrMapOvr>
+  <p:timing>
+    <p:tnLst>
+      <p:par>
+        <p:cTn id="1" dur="indefinite" restart="never" nodeType="tmRoot">
+          <p:childTnLst>
+            <p:seq concurrent="1" nextAc="seek">
+              <p:cTn id="2" dur="indefinite" nodeType="mainSeq">
+                <p:childTnLst>
+                  <p:par>
+                    <p:cTn id="3" fill="hold">
+                      <p:stCondLst>
+                        <p:cond delay="indefinite"/>
+                      </p:stCondLst>
+                      <p:childTnLst>
+                        <p:par>
+                          <p:cTn id="4" fill="hold">
+                            <p:stCondLst>
+                              <p:cond delay="0"/>
+                            </p:stCondLst>
+                            <p:childTnLst>
+                              <p:par>
+                                <p:cTn id="5" presetID="22" presetClass="exit" presetSubtype="4" fill="hold" nodeType="clickEffect">
+                                  <p:stCondLst>
+                                    <p:cond delay="0"/>
+                                  </p:stCondLst>
+                                  <p:childTnLst>
+                                    <p:animEffect transition="out" filter="wipe(down)">
+                                      <p:cBhvr>
+                                        <p:cTn id="6" dur="500"/>
+                                        <p:tgtEl>
+                                          <p:spTgt spid="14"/>
+                                        </p:tgtEl>
+                                      </p:cBhvr>
+                                    </p:animEffect>
+                                    <p:set>
+                                      <p:cBhvr>
+                                        <p:cTn id="7" dur="1" fill="hold">
+                                          <p:stCondLst>
+                                            <p:cond delay="499"/>
+                                          </p:stCondLst>
+                                        </p:cTn>
+                                        <p:tgtEl>
+                                          <p:spTgt spid="14"/>
+                                        </p:tgtEl>
+                                        <p:attrNameLst>
+                                          <p:attrName>style.visibility</p:attrName>
+                                        </p:attrNameLst>
+                                      </p:cBhvr>
+                                      <p:to>
+                                        <p:strVal val="hidden"/>
+                                      </p:to>
+                                    </p:set>
+                                  </p:childTnLst>
+                                </p:cTn>
+                              </p:par>
+                            </p:childTnLst>
+                          </p:cTn>
+                        </p:par>
+                        <p:par>
+                          <p:cTn id="8" fill="hold">
+                            <p:stCondLst>
+                              <p:cond delay="500"/>
+                            </p:stCondLst>
+                            <p:childTnLst>
+                              <p:par>
+                                <p:cTn id="9" presetID="1" presetClass="entr" presetSubtype="0" fill="hold" nodeType="afterEffect">
+                                  <p:stCondLst>
+                                    <p:cond delay="0"/>
+                                  </p:stCondLst>
+                                  <p:childTnLst>
+                                    <p:set>
+                                      <p:cBhvr>
+                                        <p:cTn id="10" dur="1" fill="hold">
+                                          <p:stCondLst>
+                                            <p:cond delay="0"/>
+                                          </p:stCondLst>
+                                        </p:cTn>
+                                        <p:tgtEl>
+                                          <p:spTgt spid="15"/>
+                                        </p:tgtEl>
+                                        <p:attrNameLst>
+                                          <p:attrName>style.visibility</p:attrName>
+                                        </p:attrNameLst>
+                                      </p:cBhvr>
+                                      <p:to>
+                                        <p:strVal val="visible"/>
+                                      </p:to>
+                                    </p:set>
+                                  </p:childTnLst>
+                                </p:cTn>
+                              </p:par>
+                            </p:childTnLst>
+                          </p:cTn>
+                        </p:par>
+                        <p:par>
+                          <p:cTn id="11" fill="hold">
+                            <p:stCondLst>
+                              <p:cond delay="500"/>
+                            </p:stCondLst>
+                            <p:childTnLst>
+                              <p:par>
+                                <p:cTn id="12" presetID="1" presetClass="entr" presetSubtype="0" fill="hold" nodeType="afterEffect">
+                                  <p:stCondLst>
+                                    <p:cond delay="0"/>
+                                  </p:stCondLst>
+                                  <p:childTnLst>
+                                    <p:set>
+                                      <p:cBhvr>
+                                        <p:cTn id="13" dur="1" fill="hold">
+                                          <p:stCondLst>
+                                            <p:cond delay="0"/>
+                                          </p:stCondLst>
+                                        </p:cTn>
+                                        <p:tgtEl>
+                                          <p:spTgt spid="9"/>
+                                        </p:tgtEl>
+                                        <p:attrNameLst>
+                                          <p:attrName>style.visibility</p:attrName>
+                                        </p:attrNameLst>
+                                      </p:cBhvr>
+                                      <p:to>
+                                        <p:strVal val="visible"/>
+                                      </p:to>
+                                    </p:set>
+                                  </p:childTnLst>
+                                </p:cTn>
+                              </p:par>
+                              <p:par>
+                                <p:cTn id="14" presetID="1" presetClass="entr" presetSubtype="0" fill="hold" nodeType="withEffect">
+                                  <p:stCondLst>
+                                    <p:cond delay="0"/>
+                                  </p:stCondLst>
+                                  <p:childTnLst>
+                                    <p:set>
+                                      <p:cBhvr>
+                                        <p:cTn id="15" dur="1" fill="hold">
+                                          <p:stCondLst>
+                                            <p:cond delay="0"/>
+                                          </p:stCondLst>
+                                        </p:cTn>
+                                        <p:tgtEl>
+                                          <p:spTgt spid="11"/>
+                                        </p:tgtEl>
+                                        <p:attrNameLst>
+                                          <p:attrName>style.visibility</p:attrName>
+                                        </p:attrNameLst>
+                                      </p:cBhvr>
+                                      <p:to>
+                                        <p:strVal val="visible"/>
+                                      </p:to>
+                                    </p:set>
+                                  </p:childTnLst>
+                                </p:cTn>
+                              </p:par>
+                              <p:par>
+                                <p:cTn id="16" presetID="1" presetClass="entr" presetSubtype="0" fill="hold" nodeType="withEffect">
+                                  <p:stCondLst>
+                                    <p:cond delay="0"/>
+                                  </p:stCondLst>
+                                  <p:childTnLst>
+                                    <p:set>
+                                      <p:cBhvr>
+                                        <p:cTn id="17" dur="1" fill="hold">
+                                          <p:stCondLst>
+                                            <p:cond delay="0"/>
+                                          </p:stCondLst>
+                                        </p:cTn>
+                                        <p:tgtEl>
+                                          <p:spTgt spid="12"/>
+                                        </p:tgtEl>
+                                        <p:attrNameLst>
+                                          <p:attrName>style.visibility</p:attrName>
+                                        </p:attrNameLst>
+                                      </p:cBhvr>
+                                      <p:to>
+                                        <p:strVal val="visible"/>
+                                      </p:to>
+                                    </p:set>
+                                  </p:childTnLst>
+                                </p:cTn>
+                              </p:par>
+                            </p:childTnLst>
+                          </p:cTn>
+                        </p:par>
+                      </p:childTnLst>
+                    </p:cTn>
+                  </p:par>
+                </p:childTnLst>
+              </p:cTn>
+              <p:prevCondLst>
+                <p:cond evt="onPrev" delay="0">
+                  <p:tgtEl>
+                    <p:sldTgt/>
+                  </p:tgtEl>
+                </p:cond>
+              </p:prevCondLst>
+              <p:nextCondLst>
+                <p:cond evt="onNext" delay="0">
+                  <p:tgtEl>
+                    <p:sldTgt/>
+                  </p:tgtEl>
+                </p:cond>
+              </p:nextCondLst>
+            </p:seq>
+          </p:childTnLst>
+        </p:cTn>
+      </p:par>
+    </p:tnLst>
+  </p:timing>
+</p:sld>
+</file>
+
+<file path=ppt/slides/slide5.xml><?xml version="1.0" encoding="utf-8"?>
+<p:sld xmlns:a="http://schemas.openxmlformats.org/drawingml/2006/main" xmlns:r="http://schemas.openxmlformats.org/officeDocument/2006/relationships" xmlns:p="http://schemas.openxmlformats.org/presentationml/2006/main">
+  <p:cSld>
+    <p:spTree>
+      <p:nvGrpSpPr>
+        <p:cNvPr id="1" name=""/>
+        <p:cNvGrpSpPr/>
+        <p:nvPr/>
+      </p:nvGrpSpPr>
+      <p:grpSpPr>
+        <a:xfrm>
+          <a:off x="0" y="0"/>
+          <a:ext cx="0" cy="0"/>
+          <a:chOff x="0" y="0"/>
+          <a:chExt cx="0" cy="0"/>
+        </a:xfrm>
+      </p:grpSpPr>
+      <p:pic>
+        <p:nvPicPr>
+          <p:cNvPr id="7" name="圖片 6">
+            <a:extLst>
+              <a:ext uri="{FF2B5EF4-FFF2-40B4-BE49-F238E27FC236}">
+                <a16:creationId xmlns:a16="http://schemas.microsoft.com/office/drawing/2014/main" id="{B6FC4D14-A389-B148-61A8-35E35BD19DBB}"/>
+              </a:ext>
+            </a:extLst>
+          </p:cNvPr>
+          <p:cNvPicPr>
+            <a:picLocks noChangeAspect="1"/>
+          </p:cNvPicPr>
+          <p:nvPr/>
+        </p:nvPicPr>
+        <p:blipFill>
+          <a:blip r:embed="rId2"/>
+          <a:stretch>
+            <a:fillRect/>
+          </a:stretch>
+        </p:blipFill>
+        <p:spPr>
+          <a:xfrm>
+            <a:off x="1831023" y="696460"/>
+            <a:ext cx="8392747" cy="6112900"/>
+          </a:xfrm>
+          <a:prstGeom prst="rect">
+            <a:avLst/>
+          </a:prstGeom>
+        </p:spPr>
+      </p:pic>
+      <p:grpSp>
+        <p:nvGrpSpPr>
+          <p:cNvPr id="8" name="群組 7">
+            <a:extLst>
+              <a:ext uri="{FF2B5EF4-FFF2-40B4-BE49-F238E27FC236}">
+                <a16:creationId xmlns:a16="http://schemas.microsoft.com/office/drawing/2014/main" id="{94F8514F-6E38-F499-F46E-A74CB895F8A3}"/>
+              </a:ext>
+            </a:extLst>
+          </p:cNvPr>
+          <p:cNvGrpSpPr/>
+          <p:nvPr/>
+        </p:nvGrpSpPr>
+        <p:grpSpPr>
+          <a:xfrm>
+            <a:off x="4505325" y="262028"/>
+            <a:ext cx="2971800" cy="1076325"/>
+            <a:chOff x="4505325" y="466311"/>
+            <a:chExt cx="2971800" cy="1076325"/>
+          </a:xfrm>
+        </p:grpSpPr>
+        <p:pic>
+          <p:nvPicPr>
+            <p:cNvPr id="9" name="圖形 8">
+              <a:extLst>
+                <a:ext uri="{FF2B5EF4-FFF2-40B4-BE49-F238E27FC236}">
+                  <a16:creationId xmlns:a16="http://schemas.microsoft.com/office/drawing/2014/main" id="{F91A057D-4812-AE58-685E-33D3401410C8}"/>
+                </a:ext>
+              </a:extLst>
+            </p:cNvPr>
+            <p:cNvPicPr>
+              <a:picLocks noChangeAspect="1"/>
+            </p:cNvPicPr>
+            <p:nvPr/>
+          </p:nvPicPr>
+          <p:blipFill>
+            <a:blip>
+              <a:extLst>
+                <a:ext uri="{96DAC541-7B7A-43D3-8B79-37D633B846F1}">
+                  <asvg:svgBlip xmlns:asvg="http://schemas.microsoft.com/office/drawing/2016/SVG/main" r:embed="rId3"/>
+                </a:ext>
+              </a:extLst>
+            </a:blip>
+            <a:stretch>
+              <a:fillRect/>
+            </a:stretch>
+          </p:blipFill>
+          <p:spPr>
+            <a:xfrm>
+              <a:off x="4505325" y="466311"/>
+              <a:ext cx="1076325" cy="1076325"/>
+            </a:xfrm>
+            <a:prstGeom prst="rect">
+              <a:avLst/>
+            </a:prstGeom>
+          </p:spPr>
+        </p:pic>
+        <p:pic>
+          <p:nvPicPr>
+            <p:cNvPr id="10" name="圖形 9">
+              <a:extLst>
+                <a:ext uri="{FF2B5EF4-FFF2-40B4-BE49-F238E27FC236}">
+                  <a16:creationId xmlns:a16="http://schemas.microsoft.com/office/drawing/2014/main" id="{41676DB9-34CA-1814-29FB-5EC25CF9E2FB}"/>
+                </a:ext>
+              </a:extLst>
+            </p:cNvPr>
+            <p:cNvPicPr>
+              <a:picLocks noChangeAspect="1"/>
+            </p:cNvPicPr>
+            <p:nvPr/>
+          </p:nvPicPr>
+          <p:blipFill>
+            <a:blip>
+              <a:extLst>
+                <a:ext uri="{96DAC541-7B7A-43D3-8B79-37D633B846F1}">
+                  <asvg:svgBlip xmlns:asvg="http://schemas.microsoft.com/office/drawing/2016/SVG/main" r:embed="rId3"/>
+                </a:ext>
+              </a:extLst>
+            </a:blip>
+            <a:stretch>
+              <a:fillRect/>
+            </a:stretch>
+          </p:blipFill>
+          <p:spPr>
+            <a:xfrm>
+              <a:off x="6400800" y="466311"/>
+              <a:ext cx="1076325" cy="1076325"/>
+            </a:xfrm>
+            <a:prstGeom prst="rect">
+              <a:avLst/>
+            </a:prstGeom>
+          </p:spPr>
+        </p:pic>
+      </p:grpSp>
+      <p:cxnSp>
+        <p:nvCxnSpPr>
+          <p:cNvPr id="13" name="直線接點 12">
+            <a:extLst>
+              <a:ext uri="{FF2B5EF4-FFF2-40B4-BE49-F238E27FC236}">
+                <a16:creationId xmlns:a16="http://schemas.microsoft.com/office/drawing/2014/main" id="{62BCAF6D-4407-BC98-058B-F73C0D2E18DD}"/>
+              </a:ext>
+            </a:extLst>
+          </p:cNvPr>
+          <p:cNvCxnSpPr>
+            <a:cxnSpLocks/>
+          </p:cNvCxnSpPr>
+          <p:nvPr/>
+        </p:nvCxnSpPr>
+        <p:spPr>
+          <a:xfrm>
+            <a:off x="5214026" y="2331101"/>
+            <a:ext cx="1634246" cy="0"/>
+          </a:xfrm>
+          <a:prstGeom prst="line">
+            <a:avLst/>
+          </a:prstGeom>
+          <a:ln w="76200">
+            <a:solidFill>
+              <a:srgbClr val="0070C0"/>
+            </a:solidFill>
+            <a:prstDash val="dash"/>
+          </a:ln>
+        </p:spPr>
+        <p:style>
+          <a:lnRef idx="2">
+            <a:schemeClr val="accent1"/>
+          </a:lnRef>
+          <a:fillRef idx="0">
+            <a:schemeClr val="accent1"/>
+          </a:fillRef>
+          <a:effectRef idx="1">
+            <a:schemeClr val="accent1"/>
+          </a:effectRef>
+          <a:fontRef idx="minor">
+            <a:schemeClr val="tx1"/>
+          </a:fontRef>
+        </p:style>
+      </p:cxnSp>
+      <p:cxnSp>
+        <p:nvCxnSpPr>
+          <p:cNvPr id="19" name="直線接點 18">
+            <a:extLst>
+              <a:ext uri="{FF2B5EF4-FFF2-40B4-BE49-F238E27FC236}">
+                <a16:creationId xmlns:a16="http://schemas.microsoft.com/office/drawing/2014/main" id="{C519280F-6C5C-1FED-6B78-5F97D7FB00B6}"/>
+              </a:ext>
+            </a:extLst>
+          </p:cNvPr>
+          <p:cNvCxnSpPr/>
+          <p:nvPr/>
+        </p:nvCxnSpPr>
+        <p:spPr>
+          <a:xfrm>
+            <a:off x="5186317" y="1588653"/>
+            <a:ext cx="4179356" cy="0"/>
+          </a:xfrm>
+          <a:prstGeom prst="line">
+            <a:avLst/>
+          </a:prstGeom>
+          <a:ln w="76200">
+            <a:solidFill>
+              <a:srgbClr val="049434"/>
+            </a:solidFill>
+          </a:ln>
+        </p:spPr>
+        <p:style>
+          <a:lnRef idx="2">
+            <a:schemeClr val="accent1"/>
+          </a:lnRef>
+          <a:fillRef idx="0">
+            <a:schemeClr val="accent1"/>
+          </a:fillRef>
+          <a:effectRef idx="1">
+            <a:schemeClr val="accent1"/>
+          </a:effectRef>
+          <a:fontRef idx="minor">
+            <a:schemeClr val="tx1"/>
+          </a:fontRef>
+        </p:style>
+      </p:cxnSp>
+    </p:spTree>
+    <p:extLst>
+      <p:ext uri="{BB962C8B-B14F-4D97-AF65-F5344CB8AC3E}">
+        <p14:creationId xmlns:p14="http://schemas.microsoft.com/office/powerpoint/2010/main" val="2160912273"/>
+      </p:ext>
+    </p:extLst>
+  </p:cSld>
+  <p:clrMapOvr>
+    <a:masterClrMapping/>
+  </p:clrMapOvr>
+  <p:timing>
+    <p:tnLst>
+      <p:par>
+        <p:cTn id="1" dur="indefinite" restart="never" nodeType="tmRoot">
+          <p:childTnLst>
+            <p:seq concurrent="1" nextAc="seek">
+              <p:cTn id="2" dur="indefinite" nodeType="mainSeq">
+                <p:childTnLst>
+                  <p:par>
+                    <p:cTn id="3" fill="hold">
+                      <p:stCondLst>
+                        <p:cond delay="indefinite"/>
+                      </p:stCondLst>
+                      <p:childTnLst>
+                        <p:par>
+                          <p:cTn id="4" fill="hold">
+                            <p:stCondLst>
+                              <p:cond delay="0"/>
+                            </p:stCondLst>
+                            <p:childTnLst>
+                              <p:par>
+                                <p:cTn id="5" presetID="42" presetClass="path" presetSubtype="0" accel="50000" decel="50000" fill="hold" nodeType="clickEffect">
+                                  <p:stCondLst>
+                                    <p:cond delay="0"/>
+                                  </p:stCondLst>
+                                  <p:childTnLst>
+                                    <p:animMotion origin="layout" path="M -1.45833E-6 -4.81481E-6 L 0.00078 -0.1081 " pathEditMode="relative" rAng="0" ptsTypes="AA">
+                                      <p:cBhvr>
+                                        <p:cTn id="6" dur="2000" fill="hold"/>
+                                        <p:tgtEl>
+                                          <p:spTgt spid="13"/>
+                                        </p:tgtEl>
+                                        <p:attrNameLst>
+                                          <p:attrName>ppt_x</p:attrName>
+                                          <p:attrName>ppt_y</p:attrName>
+                                        </p:attrNameLst>
+                                      </p:cBhvr>
+                                      <p:rCtr x="39" y="-5417"/>
+                                    </p:animMotion>
+                                  </p:childTnLst>
+                                </p:cTn>
+                              </p:par>
+                            </p:childTnLst>
+                          </p:cTn>
+                        </p:par>
+                        <p:par>
+                          <p:cTn id="7" fill="hold">
+                            <p:stCondLst>
+                              <p:cond delay="2000"/>
+                            </p:stCondLst>
+                            <p:childTnLst>
+                              <p:par>
+                                <p:cTn id="8" presetID="1" presetClass="entr" presetSubtype="0" fill="hold" nodeType="afterEffect">
+                                  <p:stCondLst>
+                                    <p:cond delay="0"/>
+                                  </p:stCondLst>
+                                  <p:childTnLst>
+                                    <p:set>
+                                      <p:cBhvr>
+                                        <p:cTn id="9" dur="1" fill="hold">
+                                          <p:stCondLst>
+                                            <p:cond delay="0"/>
+                                          </p:stCondLst>
+                                        </p:cTn>
+                                        <p:tgtEl>
+                                          <p:spTgt spid="19"/>
+                                        </p:tgtEl>
+                                        <p:attrNameLst>
+                                          <p:attrName>style.visibility</p:attrName>
+                                        </p:attrNameLst>
+                                      </p:cBhvr>
+                                      <p:to>
+                                        <p:strVal val="visible"/>
+                                      </p:to>
+                                    </p:set>
+                                  </p:childTnLst>
+                                </p:cTn>
+                              </p:par>
+                            </p:childTnLst>
+                          </p:cTn>
+                        </p:par>
+                      </p:childTnLst>
+                    </p:cTn>
+                  </p:par>
+                </p:childTnLst>
+              </p:cTn>
+              <p:prevCondLst>
+                <p:cond evt="onPrev" delay="0">
+                  <p:tgtEl>
+                    <p:sldTgt/>
+                  </p:tgtEl>
+                </p:cond>
+              </p:prevCondLst>
+              <p:nextCondLst>
+                <p:cond evt="onNext" delay="0">
+                  <p:tgtEl>
+                    <p:sldTgt/>
+                  </p:tgtEl>
+                </p:cond>
+              </p:nextCondLst>
+            </p:seq>
+          </p:childTnLst>
+        </p:cTn>
+      </p:par>
+    </p:tnLst>
+  </p:timing>
+</p:sld>
+</file>
+
+<file path=ppt/slides/slide6.xml><?xml version="1.0" encoding="utf-8"?>
+<p:sld xmlns:a="http://schemas.openxmlformats.org/drawingml/2006/main" xmlns:r="http://schemas.openxmlformats.org/officeDocument/2006/relationships" xmlns:p="http://schemas.openxmlformats.org/presentationml/2006/main">
+  <p:cSld>
+    <p:spTree>
+      <p:nvGrpSpPr>
+        <p:cNvPr id="1" name=""/>
+        <p:cNvGrpSpPr/>
+        <p:nvPr/>
+      </p:nvGrpSpPr>
+      <p:grpSpPr>
+        <a:xfrm>
+          <a:off x="0" y="0"/>
+          <a:ext cx="0" cy="0"/>
+          <a:chOff x="0" y="0"/>
+          <a:chExt cx="0" cy="0"/>
+        </a:xfrm>
+      </p:grpSpPr>
+      <p:pic>
+        <p:nvPicPr>
+          <p:cNvPr id="5" name="圖片 4">
+            <a:extLst>
+              <a:ext uri="{FF2B5EF4-FFF2-40B4-BE49-F238E27FC236}">
+                <a16:creationId xmlns:a16="http://schemas.microsoft.com/office/drawing/2014/main" id="{FB4874DA-BD76-C36F-7C40-9C16C5A4E03D}"/>
+              </a:ext>
+            </a:extLst>
+          </p:cNvPr>
+          <p:cNvPicPr>
+            <a:picLocks noChangeAspect="1"/>
+          </p:cNvPicPr>
+          <p:nvPr/>
+        </p:nvPicPr>
+        <p:blipFill>
+          <a:blip r:embed="rId2">
+            <a:extLst>
+              <a:ext uri="{28A0092B-C50C-407E-A947-70E740481C1C}">
+                <a14:useLocalDpi xmlns:a14="http://schemas.microsoft.com/office/drawing/2010/main" val="0"/>
+              </a:ext>
+            </a:extLst>
+          </a:blip>
+          <a:stretch>
+            <a:fillRect/>
+          </a:stretch>
+        </p:blipFill>
+        <p:spPr>
+          <a:xfrm>
+            <a:off x="2433678" y="0"/>
+            <a:ext cx="7324644" cy="6858000"/>
+          </a:xfrm>
+          <a:prstGeom prst="rect">
+            <a:avLst/>
+          </a:prstGeom>
+        </p:spPr>
+      </p:pic>
+    </p:spTree>
+    <p:extLst>
+      <p:ext uri="{BB962C8B-B14F-4D97-AF65-F5344CB8AC3E}">
+        <p14:creationId xmlns:p14="http://schemas.microsoft.com/office/powerpoint/2010/main" val="3408930596"/>
+      </p:ext>
+    </p:extLst>
+  </p:cSld>
+  <p:clrMapOvr>
+    <a:masterClrMapping/>
+  </p:clrMapOvr>
+</p:sld>
+</file>
+
+<file path=ppt/slides/slide7.xml><?xml version="1.0" encoding="utf-8"?>
+<p:sld xmlns:a="http://schemas.openxmlformats.org/drawingml/2006/main" xmlns:r="http://schemas.openxmlformats.org/officeDocument/2006/relationships" xmlns:p="http://schemas.openxmlformats.org/presentationml/2006/main">
+  <p:cSld>
+    <p:spTree>
+      <p:nvGrpSpPr>
+        <p:cNvPr id="1" name=""/>
+        <p:cNvGrpSpPr/>
+        <p:nvPr/>
+      </p:nvGrpSpPr>
+      <p:grpSpPr>
+        <a:xfrm>
+          <a:off x="0" y="0"/>
+          <a:ext cx="0" cy="0"/>
+          <a:chOff x="0" y="0"/>
+          <a:chExt cx="0" cy="0"/>
+        </a:xfrm>
+      </p:grpSpPr>
+      <p:sp>
+        <p:nvSpPr>
+          <p:cNvPr id="2" name="標題 1">
+            <a:extLst>
+              <a:ext uri="{FF2B5EF4-FFF2-40B4-BE49-F238E27FC236}">
+                <a16:creationId xmlns:a16="http://schemas.microsoft.com/office/drawing/2014/main" id="{E51B1235-3ABB-DA3F-014D-656267C12433}"/>
+              </a:ext>
+            </a:extLst>
+          </p:cNvPr>
+          <p:cNvSpPr>
+            <a:spLocks noGrp="1"/>
+          </p:cNvSpPr>
+          <p:nvPr>
+            <p:ph type="title"/>
+          </p:nvPr>
+        </p:nvSpPr>
+        <p:spPr/>
+        <p:txBody>
+          <a:bodyPr/>
+          <a:lstStyle/>
+          <a:p>
+            <a:r>
+              <a:rPr lang="zh-TW" altLang="en-US" dirty="0"/>
+              <a:t>狀態  </a:t>
+            </a:r>
+            <a:r>
+              <a:rPr lang="en-US" altLang="zh-TW" dirty="0"/>
+              <a:t>States (Example)</a:t>
+            </a:r>
+            <a:endParaRPr lang="zh-TW" altLang="en-US" dirty="0"/>
+          </a:p>
+        </p:txBody>
+      </p:sp>
+      <p:sp>
+        <p:nvSpPr>
+          <p:cNvPr id="3" name="內容版面配置區 2">
+            <a:extLst>
+              <a:ext uri="{FF2B5EF4-FFF2-40B4-BE49-F238E27FC236}">
+                <a16:creationId xmlns:a16="http://schemas.microsoft.com/office/drawing/2014/main" id="{076BDB3D-53BF-8CEE-0AD1-E2EF46AE8F73}"/>
+              </a:ext>
+            </a:extLst>
+          </p:cNvPr>
+          <p:cNvSpPr>
+            <a:spLocks noGrp="1"/>
+          </p:cNvSpPr>
+          <p:nvPr>
+            <p:ph idx="1"/>
+          </p:nvPr>
+        </p:nvSpPr>
+        <p:spPr>
+          <a:xfrm>
+            <a:off x="838201" y="1816389"/>
+            <a:ext cx="7382164" cy="4351338"/>
+          </a:xfrm>
+        </p:spPr>
+        <p:txBody>
+          <a:bodyPr/>
+          <a:lstStyle/>
+          <a:p>
+            <a:r>
+              <a:rPr lang="zh-TW" altLang="zh-TW" dirty="0"/>
+              <a:t>🟢</a:t>
+            </a:r>
+            <a:r>
+              <a:rPr lang="en-US" altLang="zh-TW" dirty="0"/>
+              <a:t> Building</a:t>
+            </a:r>
+            <a:r>
+              <a:rPr lang="zh-TW" altLang="en-US" dirty="0"/>
+              <a:t> </a:t>
+            </a:r>
+            <a:r>
+              <a:rPr lang="en-US" altLang="zh-TW" dirty="0" err="1"/>
+              <a:t>Superconductorlike</a:t>
+            </a:r>
+            <a:r>
+              <a:rPr lang="en-US" altLang="zh-TW" dirty="0"/>
+              <a:t> Society </a:t>
+            </a:r>
+          </a:p>
+          <a:p>
+            <a:r>
+              <a:rPr lang="zh-TW" altLang="zh-TW" dirty="0"/>
+              <a:t>🟢 試著在不能接受的狀態中找到可感恩的點，並且感恩，至少三次</a:t>
+            </a:r>
+            <a:endParaRPr lang="en-US" altLang="zh-TW" dirty="0"/>
+          </a:p>
+          <a:p>
+            <a:pPr lvl="1"/>
+            <a:r>
+              <a:rPr lang="zh-TW" altLang="zh-TW" dirty="0"/>
+              <a:t>🟢 Try to find points of gratitude in unacceptable situations and express gratitude at least 3 times</a:t>
+            </a:r>
+          </a:p>
+          <a:p>
+            <a:r>
+              <a:rPr lang="zh-TW" altLang="zh-TW" dirty="0"/>
+              <a:t>⛔ 娛樂不超過 30 分鐘</a:t>
+            </a:r>
+            <a:endParaRPr lang="en-US" altLang="zh-TW" dirty="0"/>
+          </a:p>
+          <a:p>
+            <a:pPr lvl="1"/>
+            <a:r>
+              <a:rPr lang="zh-TW" altLang="zh-TW" dirty="0"/>
+              <a:t>⛔ Entertainment not exceeding 30 minutes</a:t>
+            </a:r>
+          </a:p>
+          <a:p>
+            <a:r>
+              <a:rPr lang="zh-TW" altLang="zh-TW" dirty="0"/>
+              <a:t>⛔ 發脾氣不超過十次與不超過 10 分鐘</a:t>
+            </a:r>
+            <a:endParaRPr lang="en-US" altLang="zh-TW" dirty="0"/>
+          </a:p>
+          <a:p>
+            <a:pPr lvl="1"/>
+            <a:r>
+              <a:rPr lang="zh-TW" altLang="zh-TW" dirty="0"/>
+              <a:t>⛔ Anger more than 10 times and more than 10 minutes</a:t>
+            </a:r>
+          </a:p>
+          <a:p>
+            <a:endParaRPr lang="zh-TW" altLang="en-US" dirty="0"/>
+          </a:p>
+        </p:txBody>
+      </p:sp>
+    </p:spTree>
+    <p:extLst>
+      <p:ext uri="{BB962C8B-B14F-4D97-AF65-F5344CB8AC3E}">
+        <p14:creationId xmlns:p14="http://schemas.microsoft.com/office/powerpoint/2010/main" val="848532407"/>
+      </p:ext>
+    </p:extLst>
+  </p:cSld>
+  <p:clrMapOvr>
+    <a:masterClrMapping/>
+  </p:clrMapOvr>
+  <p:timing>
+    <p:tnLst>
+      <p:par>
+        <p:cTn id="1" dur="indefinite" restart="never" nodeType="tmRoot">
+          <p:childTnLst>
+            <p:seq concurrent="1" nextAc="seek">
+              <p:cTn id="2" dur="indefinite" nodeType="mainSeq">
+                <p:childTnLst>
+                  <p:par>
+                    <p:cTn id="3" fill="hold">
+                      <p:stCondLst>
+                        <p:cond delay="indefinite"/>
+                      </p:stCondLst>
+                      <p:childTnLst>
+                        <p:par>
+                          <p:cTn id="4" fill="hold">
+                            <p:stCondLst>
+                              <p:cond delay="0"/>
+                            </p:stCondLst>
+                            <p:childTnLst>
+                              <p:par>
+                                <p:cTn id="5" presetID="2" presetClass="entr" presetSubtype="4" fill="hold" grpId="0" nodeType="clickEffect">
+                                  <p:stCondLst>
+                                    <p:cond delay="0"/>
+                                  </p:stCondLst>
+                                  <p:childTnLst>
+                                    <p:set>
+                                      <p:cBhvr>
+                                        <p:cTn id="6" dur="1" fill="hold">
+                                          <p:stCondLst>
+                                            <p:cond delay="0"/>
+                                          </p:stCondLst>
+                                        </p:cTn>
+                                        <p:tgtEl>
+                                          <p:spTgt spid="3">
+                                            <p:txEl>
+                                              <p:pRg st="0" end="0"/>
+                                            </p:txEl>
+                                          </p:spTgt>
+                                        </p:tgtEl>
+                                        <p:attrNameLst>
+                                          <p:attrName>style.visibility</p:attrName>
+                                        </p:attrNameLst>
+                                      </p:cBhvr>
+                                      <p:to>
+                                        <p:strVal val="visible"/>
+                                      </p:to>
+                                    </p:set>
+                                    <p:anim calcmode="lin" valueType="num">
+                                      <p:cBhvr additive="base">
+                                        <p:cTn id="7" dur="500" fill="hold"/>
+                                        <p:tgtEl>
+                                          <p:spTgt spid="3">
+                                            <p:txEl>
+                                              <p:pRg st="0" end="0"/>
+                                            </p:txEl>
+                                          </p:spTgt>
+                                        </p:tgtEl>
+                                        <p:attrNameLst>
+                                          <p:attrName>ppt_x</p:attrName>
+                                        </p:attrNameLst>
+                                      </p:cBhvr>
+                                      <p:tavLst>
+                                        <p:tav tm="0">
+                                          <p:val>
+                                            <p:strVal val="#ppt_x"/>
+                                          </p:val>
+                                        </p:tav>
+                                        <p:tav tm="100000">
+                                          <p:val>
+                                            <p:strVal val="#ppt_x"/>
+                                          </p:val>
+                                        </p:tav>
+                                      </p:tavLst>
+                                    </p:anim>
+                                    <p:anim calcmode="lin" valueType="num">
+                                      <p:cBhvr additive="base">
+                                        <p:cTn id="8" dur="500" fill="hold"/>
+                                        <p:tgtEl>
+                                          <p:spTgt spid="3">
+                                            <p:txEl>
+                                              <p:pRg st="0" end="0"/>
+                                            </p:txEl>
+                                          </p:spTgt>
+                                        </p:tgtEl>
+                                        <p:attrNameLst>
+                                          <p:attrName>ppt_y</p:attrName>
+                                        </p:attrNameLst>
+                                      </p:cBhvr>
+                                      <p:tavLst>
+                                        <p:tav tm="0">
+                                          <p:val>
+                                            <p:strVal val="1+#ppt_h/2"/>
+                                          </p:val>
+                                        </p:tav>
+                                        <p:tav tm="100000">
+                                          <p:val>
+                                            <p:strVal val="#ppt_y"/>
+                                          </p:val>
+                                        </p:tav>
+                                      </p:tavLst>
+                                    </p:anim>
+                                  </p:childTnLst>
+                                </p:cTn>
+                              </p:par>
+                            </p:childTnLst>
+                          </p:cTn>
+                        </p:par>
+                      </p:childTnLst>
+                    </p:cTn>
+                  </p:par>
+                  <p:par>
+                    <p:cTn id="9" fill="hold">
+                      <p:stCondLst>
+                        <p:cond delay="indefinite"/>
+                      </p:stCondLst>
+                      <p:childTnLst>
+                        <p:par>
+                          <p:cTn id="10" fill="hold">
+                            <p:stCondLst>
+                              <p:cond delay="0"/>
+                            </p:stCondLst>
+                            <p:childTnLst>
+                              <p:par>
+                                <p:cTn id="11" presetID="2" presetClass="entr" presetSubtype="4" fill="hold" grpId="0" nodeType="clickEffect">
+                                  <p:stCondLst>
+                                    <p:cond delay="0"/>
+                                  </p:stCondLst>
+                                  <p:childTnLst>
+                                    <p:set>
+                                      <p:cBhvr>
+                                        <p:cTn id="12" dur="1" fill="hold">
+                                          <p:stCondLst>
+                                            <p:cond delay="0"/>
+                                          </p:stCondLst>
+                                        </p:cTn>
+                                        <p:tgtEl>
+                                          <p:spTgt spid="3">
+                                            <p:txEl>
+                                              <p:pRg st="1" end="1"/>
+                                            </p:txEl>
+                                          </p:spTgt>
+                                        </p:tgtEl>
+                                        <p:attrNameLst>
+                                          <p:attrName>style.visibility</p:attrName>
+                                        </p:attrNameLst>
+                                      </p:cBhvr>
+                                      <p:to>
+                                        <p:strVal val="visible"/>
+                                      </p:to>
+                                    </p:set>
+                                    <p:anim calcmode="lin" valueType="num">
+                                      <p:cBhvr additive="base">
+                                        <p:cTn id="13" dur="500" fill="hold"/>
+                                        <p:tgtEl>
+                                          <p:spTgt spid="3">
+                                            <p:txEl>
+                                              <p:pRg st="1" end="1"/>
+                                            </p:txEl>
+                                          </p:spTgt>
+                                        </p:tgtEl>
+                                        <p:attrNameLst>
+                                          <p:attrName>ppt_x</p:attrName>
+                                        </p:attrNameLst>
+                                      </p:cBhvr>
+                                      <p:tavLst>
+                                        <p:tav tm="0">
+                                          <p:val>
+                                            <p:strVal val="#ppt_x"/>
+                                          </p:val>
+                                        </p:tav>
+                                        <p:tav tm="100000">
+                                          <p:val>
+                                            <p:strVal val="#ppt_x"/>
+                                          </p:val>
+                                        </p:tav>
+                                      </p:tavLst>
+                                    </p:anim>
+                                    <p:anim calcmode="lin" valueType="num">
+                                      <p:cBhvr additive="base">
+                                        <p:cTn id="14" dur="500" fill="hold"/>
+                                        <p:tgtEl>
+                                          <p:spTgt spid="3">
+                                            <p:txEl>
+                                              <p:pRg st="1" end="1"/>
+                                            </p:txEl>
+                                          </p:spTgt>
+                                        </p:tgtEl>
+                                        <p:attrNameLst>
+                                          <p:attrName>ppt_y</p:attrName>
+                                        </p:attrNameLst>
+                                      </p:cBhvr>
+                                      <p:tavLst>
+                                        <p:tav tm="0">
+                                          <p:val>
+                                            <p:strVal val="1+#ppt_h/2"/>
+                                          </p:val>
+                                        </p:tav>
+                                        <p:tav tm="100000">
+                                          <p:val>
+                                            <p:strVal val="#ppt_y"/>
+                                          </p:val>
+                                        </p:tav>
+                                      </p:tavLst>
+                                    </p:anim>
+                                  </p:childTnLst>
+                                </p:cTn>
+                              </p:par>
+                              <p:par>
+                                <p:cTn id="15" presetID="2" presetClass="entr" presetSubtype="4" fill="hold" grpId="0" nodeType="withEffect">
+                                  <p:stCondLst>
+                                    <p:cond delay="0"/>
+                                  </p:stCondLst>
+                                  <p:childTnLst>
+                                    <p:set>
+                                      <p:cBhvr>
+                                        <p:cTn id="16" dur="1" fill="hold">
+                                          <p:stCondLst>
+                                            <p:cond delay="0"/>
+                                          </p:stCondLst>
+                                        </p:cTn>
+                                        <p:tgtEl>
+                                          <p:spTgt spid="3">
+                                            <p:txEl>
+                                              <p:pRg st="2" end="2"/>
+                                            </p:txEl>
+                                          </p:spTgt>
+                                        </p:tgtEl>
+                                        <p:attrNameLst>
+                                          <p:attrName>style.visibility</p:attrName>
+                                        </p:attrNameLst>
+                                      </p:cBhvr>
+                                      <p:to>
+                                        <p:strVal val="visible"/>
+                                      </p:to>
+                                    </p:set>
+                                    <p:anim calcmode="lin" valueType="num">
+                                      <p:cBhvr additive="base">
+                                        <p:cTn id="17" dur="500" fill="hold"/>
+                                        <p:tgtEl>
+                                          <p:spTgt spid="3">
+                                            <p:txEl>
+                                              <p:pRg st="2" end="2"/>
+                                            </p:txEl>
+                                          </p:spTgt>
+                                        </p:tgtEl>
+                                        <p:attrNameLst>
+                                          <p:attrName>ppt_x</p:attrName>
+                                        </p:attrNameLst>
+                                      </p:cBhvr>
+                                      <p:tavLst>
+                                        <p:tav tm="0">
+                                          <p:val>
+                                            <p:strVal val="#ppt_x"/>
+                                          </p:val>
+                                        </p:tav>
+                                        <p:tav tm="100000">
+                                          <p:val>
+                                            <p:strVal val="#ppt_x"/>
+                                          </p:val>
+                                        </p:tav>
+                                      </p:tavLst>
+                                    </p:anim>
+                                    <p:anim calcmode="lin" valueType="num">
+                                      <p:cBhvr additive="base">
+                                        <p:cTn id="18" dur="500" fill="hold"/>
+                                        <p:tgtEl>
+                                          <p:spTgt spid="3">
+                                            <p:txEl>
+                                              <p:pRg st="2" end="2"/>
+                                            </p:txEl>
+                                          </p:spTgt>
+                                        </p:tgtEl>
+                                        <p:attrNameLst>
+                                          <p:attrName>ppt_y</p:attrName>
+                                        </p:attrNameLst>
+                                      </p:cBhvr>
+                                      <p:tavLst>
+                                        <p:tav tm="0">
+                                          <p:val>
+                                            <p:strVal val="1+#ppt_h/2"/>
+                                          </p:val>
+                                        </p:tav>
+                                        <p:tav tm="100000">
+                                          <p:val>
+                                            <p:strVal val="#ppt_y"/>
+                                          </p:val>
+                                        </p:tav>
+                                      </p:tavLst>
+                                    </p:anim>
+                                  </p:childTnLst>
+                                </p:cTn>
+                              </p:par>
+                            </p:childTnLst>
+                          </p:cTn>
+                        </p:par>
+                      </p:childTnLst>
+                    </p:cTn>
+                  </p:par>
+                  <p:par>
+                    <p:cTn id="19" fill="hold">
+                      <p:stCondLst>
+                        <p:cond delay="indefinite"/>
+                      </p:stCondLst>
+                      <p:childTnLst>
+                        <p:par>
+                          <p:cTn id="20" fill="hold">
+                            <p:stCondLst>
+                              <p:cond delay="0"/>
+                            </p:stCondLst>
+                            <p:childTnLst>
+                              <p:par>
+                                <p:cTn id="21" presetID="2" presetClass="entr" presetSubtype="4" fill="hold" grpId="0" nodeType="clickEffect">
+                                  <p:stCondLst>
+                                    <p:cond delay="0"/>
+                                  </p:stCondLst>
+                                  <p:childTnLst>
+                                    <p:set>
+                                      <p:cBhvr>
+                                        <p:cTn id="22" dur="1" fill="hold">
+                                          <p:stCondLst>
+                                            <p:cond delay="0"/>
+                                          </p:stCondLst>
+                                        </p:cTn>
+                                        <p:tgtEl>
+                                          <p:spTgt spid="3">
+                                            <p:txEl>
+                                              <p:pRg st="3" end="3"/>
+                                            </p:txEl>
+                                          </p:spTgt>
+                                        </p:tgtEl>
+                                        <p:attrNameLst>
+                                          <p:attrName>style.visibility</p:attrName>
+                                        </p:attrNameLst>
+                                      </p:cBhvr>
+                                      <p:to>
+                                        <p:strVal val="visible"/>
+                                      </p:to>
+                                    </p:set>
+                                    <p:anim calcmode="lin" valueType="num">
+                                      <p:cBhvr additive="base">
+                                        <p:cTn id="23" dur="500" fill="hold"/>
+                                        <p:tgtEl>
+                                          <p:spTgt spid="3">
+                                            <p:txEl>
+                                              <p:pRg st="3" end="3"/>
+                                            </p:txEl>
+                                          </p:spTgt>
+                                        </p:tgtEl>
+                                        <p:attrNameLst>
+                                          <p:attrName>ppt_x</p:attrName>
+                                        </p:attrNameLst>
+                                      </p:cBhvr>
+                                      <p:tavLst>
+                                        <p:tav tm="0">
+                                          <p:val>
+                                            <p:strVal val="#ppt_x"/>
+                                          </p:val>
+                                        </p:tav>
+                                        <p:tav tm="100000">
+                                          <p:val>
+                                            <p:strVal val="#ppt_x"/>
+                                          </p:val>
+                                        </p:tav>
+                                      </p:tavLst>
+                                    </p:anim>
+                                    <p:anim calcmode="lin" valueType="num">
+                                      <p:cBhvr additive="base">
+                                        <p:cTn id="24" dur="500" fill="hold"/>
+                                        <p:tgtEl>
+                                          <p:spTgt spid="3">
+                                            <p:txEl>
+                                              <p:pRg st="3" end="3"/>
+                                            </p:txEl>
+                                          </p:spTgt>
+                                        </p:tgtEl>
+                                        <p:attrNameLst>
+                                          <p:attrName>ppt_y</p:attrName>
+                                        </p:attrNameLst>
+                                      </p:cBhvr>
+                                      <p:tavLst>
+                                        <p:tav tm="0">
+                                          <p:val>
+                                            <p:strVal val="1+#ppt_h/2"/>
+                                          </p:val>
+                                        </p:tav>
+                                        <p:tav tm="100000">
+                                          <p:val>
+                                            <p:strVal val="#ppt_y"/>
+                                          </p:val>
+                                        </p:tav>
+                                      </p:tavLst>
+                                    </p:anim>
+                                  </p:childTnLst>
+                                </p:cTn>
+                              </p:par>
+                              <p:par>
+                                <p:cTn id="25" presetID="2" presetClass="entr" presetSubtype="4" fill="hold" grpId="0" nodeType="withEffect">
+                                  <p:stCondLst>
+                                    <p:cond delay="0"/>
+                                  </p:stCondLst>
+                                  <p:childTnLst>
+                                    <p:set>
+                                      <p:cBhvr>
+                                        <p:cTn id="26" dur="1" fill="hold">
+                                          <p:stCondLst>
+                                            <p:cond delay="0"/>
+                                          </p:stCondLst>
+                                        </p:cTn>
+                                        <p:tgtEl>
+                                          <p:spTgt spid="3">
+                                            <p:txEl>
+                                              <p:pRg st="4" end="4"/>
+                                            </p:txEl>
+                                          </p:spTgt>
+                                        </p:tgtEl>
+                                        <p:attrNameLst>
+                                          <p:attrName>style.visibility</p:attrName>
+                                        </p:attrNameLst>
+                                      </p:cBhvr>
+                                      <p:to>
+                                        <p:strVal val="visible"/>
+                                      </p:to>
+                                    </p:set>
+                                    <p:anim calcmode="lin" valueType="num">
+                                      <p:cBhvr additive="base">
+                                        <p:cTn id="27" dur="500" fill="hold"/>
+                                        <p:tgtEl>
+                                          <p:spTgt spid="3">
+                                            <p:txEl>
+                                              <p:pRg st="4" end="4"/>
+                                            </p:txEl>
+                                          </p:spTgt>
+                                        </p:tgtEl>
+                                        <p:attrNameLst>
+                                          <p:attrName>ppt_x</p:attrName>
+                                        </p:attrNameLst>
+                                      </p:cBhvr>
+                                      <p:tavLst>
+                                        <p:tav tm="0">
+                                          <p:val>
+                                            <p:strVal val="#ppt_x"/>
+                                          </p:val>
+                                        </p:tav>
+                                        <p:tav tm="100000">
+                                          <p:val>
+                                            <p:strVal val="#ppt_x"/>
+                                          </p:val>
+                                        </p:tav>
+                                      </p:tavLst>
+                                    </p:anim>
+                                    <p:anim calcmode="lin" valueType="num">
+                                      <p:cBhvr additive="base">
+                                        <p:cTn id="28" dur="500" fill="hold"/>
+                                        <p:tgtEl>
+                                          <p:spTgt spid="3">
+                                            <p:txEl>
+                                              <p:pRg st="4" end="4"/>
+                                            </p:txEl>
+                                          </p:spTgt>
+                                        </p:tgtEl>
+                                        <p:attrNameLst>
+                                          <p:attrName>ppt_y</p:attrName>
+                                        </p:attrNameLst>
+                                      </p:cBhvr>
+                                      <p:tavLst>
+                                        <p:tav tm="0">
+                                          <p:val>
+                                            <p:strVal val="1+#ppt_h/2"/>
+                                          </p:val>
+                                        </p:tav>
+                                        <p:tav tm="100000">
+                                          <p:val>
+                                            <p:strVal val="#ppt_y"/>
+                                          </p:val>
+                                        </p:tav>
+                                      </p:tavLst>
+                                    </p:anim>
+                                  </p:childTnLst>
+                                </p:cTn>
+                              </p:par>
+                            </p:childTnLst>
+                          </p:cTn>
+                        </p:par>
+                      </p:childTnLst>
+                    </p:cTn>
+                  </p:par>
+                  <p:par>
+                    <p:cTn id="29" fill="hold">
+                      <p:stCondLst>
+                        <p:cond delay="indefinite"/>
+                      </p:stCondLst>
+                      <p:childTnLst>
+                        <p:par>
+                          <p:cTn id="30" fill="hold">
+                            <p:stCondLst>
+                              <p:cond delay="0"/>
+                            </p:stCondLst>
+                            <p:childTnLst>
+                              <p:par>
+                                <p:cTn id="31" presetID="2" presetClass="entr" presetSubtype="4" fill="hold" grpId="0" nodeType="clickEffect">
+                                  <p:stCondLst>
+                                    <p:cond delay="0"/>
+                                  </p:stCondLst>
+                                  <p:childTnLst>
+                                    <p:set>
+                                      <p:cBhvr>
+                                        <p:cTn id="32" dur="1" fill="hold">
+                                          <p:stCondLst>
+                                            <p:cond delay="0"/>
+                                          </p:stCondLst>
+                                        </p:cTn>
+                                        <p:tgtEl>
+                                          <p:spTgt spid="3">
+                                            <p:txEl>
+                                              <p:pRg st="5" end="5"/>
+                                            </p:txEl>
+                                          </p:spTgt>
+                                        </p:tgtEl>
+                                        <p:attrNameLst>
+                                          <p:attrName>style.visibility</p:attrName>
+                                        </p:attrNameLst>
+                                      </p:cBhvr>
+                                      <p:to>
+                                        <p:strVal val="visible"/>
+                                      </p:to>
+                                    </p:set>
+                                    <p:anim calcmode="lin" valueType="num">
+                                      <p:cBhvr additive="base">
+                                        <p:cTn id="33" dur="500" fill="hold"/>
+                                        <p:tgtEl>
+                                          <p:spTgt spid="3">
+                                            <p:txEl>
+                                              <p:pRg st="5" end="5"/>
+                                            </p:txEl>
+                                          </p:spTgt>
+                                        </p:tgtEl>
+                                        <p:attrNameLst>
+                                          <p:attrName>ppt_x</p:attrName>
+                                        </p:attrNameLst>
+                                      </p:cBhvr>
+                                      <p:tavLst>
+                                        <p:tav tm="0">
+                                          <p:val>
+                                            <p:strVal val="#ppt_x"/>
+                                          </p:val>
+                                        </p:tav>
+                                        <p:tav tm="100000">
+                                          <p:val>
+                                            <p:strVal val="#ppt_x"/>
+                                          </p:val>
+                                        </p:tav>
+                                      </p:tavLst>
+                                    </p:anim>
+                                    <p:anim calcmode="lin" valueType="num">
+                                      <p:cBhvr additive="base">
+                                        <p:cTn id="34" dur="500" fill="hold"/>
+                                        <p:tgtEl>
+                                          <p:spTgt spid="3">
+                                            <p:txEl>
+                                              <p:pRg st="5" end="5"/>
+                                            </p:txEl>
+                                          </p:spTgt>
+                                        </p:tgtEl>
+                                        <p:attrNameLst>
+                                          <p:attrName>ppt_y</p:attrName>
+                                        </p:attrNameLst>
+                                      </p:cBhvr>
+                                      <p:tavLst>
+                                        <p:tav tm="0">
+                                          <p:val>
+                                            <p:strVal val="1+#ppt_h/2"/>
+                                          </p:val>
+                                        </p:tav>
+                                        <p:tav tm="100000">
+                                          <p:val>
+                                            <p:strVal val="#ppt_y"/>
+                                          </p:val>
+                                        </p:tav>
+                                      </p:tavLst>
+                                    </p:anim>
+                                  </p:childTnLst>
+                                </p:cTn>
+                              </p:par>
+                              <p:par>
+                                <p:cTn id="35" presetID="2" presetClass="entr" presetSubtype="4" fill="hold" grpId="0" nodeType="withEffect">
+                                  <p:stCondLst>
+                                    <p:cond delay="0"/>
+                                  </p:stCondLst>
+                                  <p:childTnLst>
+                                    <p:set>
+                                      <p:cBhvr>
+                                        <p:cTn id="36" dur="1" fill="hold">
+                                          <p:stCondLst>
+                                            <p:cond delay="0"/>
+                                          </p:stCondLst>
+                                        </p:cTn>
+                                        <p:tgtEl>
+                                          <p:spTgt spid="3">
+                                            <p:txEl>
+                                              <p:pRg st="6" end="6"/>
+                                            </p:txEl>
+                                          </p:spTgt>
+                                        </p:tgtEl>
+                                        <p:attrNameLst>
+                                          <p:attrName>style.visibility</p:attrName>
+                                        </p:attrNameLst>
+                                      </p:cBhvr>
+                                      <p:to>
+                                        <p:strVal val="visible"/>
+                                      </p:to>
+                                    </p:set>
+                                    <p:anim calcmode="lin" valueType="num">
+                                      <p:cBhvr additive="base">
+                                        <p:cTn id="37" dur="500" fill="hold"/>
+                                        <p:tgtEl>
+                                          <p:spTgt spid="3">
+                                            <p:txEl>
+                                              <p:pRg st="6" end="6"/>
+                                            </p:txEl>
+                                          </p:spTgt>
+                                        </p:tgtEl>
+                                        <p:attrNameLst>
+                                          <p:attrName>ppt_x</p:attrName>
+                                        </p:attrNameLst>
+                                      </p:cBhvr>
+                                      <p:tavLst>
+                                        <p:tav tm="0">
+                                          <p:val>
+                                            <p:strVal val="#ppt_x"/>
+                                          </p:val>
+                                        </p:tav>
+                                        <p:tav tm="100000">
+                                          <p:val>
+                                            <p:strVal val="#ppt_x"/>
+                                          </p:val>
+                                        </p:tav>
+                                      </p:tavLst>
+                                    </p:anim>
+                                    <p:anim calcmode="lin" valueType="num">
+                                      <p:cBhvr additive="base">
+                                        <p:cTn id="38" dur="500" fill="hold"/>
+                                        <p:tgtEl>
+                                          <p:spTgt spid="3">
+                                            <p:txEl>
+                                              <p:pRg st="6" end="6"/>
+                                            </p:txEl>
+                                          </p:spTgt>
+                                        </p:tgtEl>
+                                        <p:attrNameLst>
+                                          <p:attrName>ppt_y</p:attrName>
+                                        </p:attrNameLst>
+                                      </p:cBhvr>
+                                      <p:tavLst>
+                                        <p:tav tm="0">
+                                          <p:val>
+                                            <p:strVal val="1+#ppt_h/2"/>
+                                          </p:val>
+                                        </p:tav>
+                                        <p:tav tm="100000">
+                                          <p:val>
+                                            <p:strVal val="#ppt_y"/>
+                                          </p:val>
+                                        </p:tav>
+                                      </p:tavLst>
+                                    </p:anim>
+                                  </p:childTnLst>
+                                </p:cTn>
+                              </p:par>
+                            </p:childTnLst>
+                          </p:cTn>
+                        </p:par>
+                      </p:childTnLst>
+                    </p:cTn>
+                  </p:par>
+                </p:childTnLst>
+              </p:cTn>
+              <p:prevCondLst>
+                <p:cond evt="onPrev" delay="0">
+                  <p:tgtEl>
+                    <p:sldTgt/>
+                  </p:tgtEl>
+                </p:cond>
+              </p:prevCondLst>
+              <p:nextCondLst>
+                <p:cond evt="onNext" delay="0">
+                  <p:tgtEl>
+                    <p:sldTgt/>
+                  </p:tgtEl>
+                </p:cond>
+              </p:nextCondLst>
+            </p:seq>
+          </p:childTnLst>
+        </p:cTn>
+      </p:par>
+    </p:tnLst>
+    <p:bldLst>
+      <p:bldP spid="3" grpId="0" build="p"/>
+    </p:bldLst>
+  </p:timing>
+</p:sld>
+</file>
+
+<file path=ppt/slides/slide8.xml><?xml version="1.0" encoding="utf-8"?>
+<p:sld xmlns:a="http://schemas.openxmlformats.org/drawingml/2006/main" xmlns:r="http://schemas.openxmlformats.org/officeDocument/2006/relationships" xmlns:p="http://schemas.openxmlformats.org/presentationml/2006/main">
+  <p:cSld>
+    <p:spTree>
+      <p:nvGrpSpPr>
+        <p:cNvPr id="1" name="">
+          <a:extLst>
+            <a:ext uri="{FF2B5EF4-FFF2-40B4-BE49-F238E27FC236}">
+              <a16:creationId xmlns:a16="http://schemas.microsoft.com/office/drawing/2014/main" id="{220B2E47-1927-6CE6-13CE-4898FF5EF685}"/>
+            </a:ext>
+          </a:extLst>
+        </p:cNvPr>
+        <p:cNvGrpSpPr/>
+        <p:nvPr/>
+      </p:nvGrpSpPr>
+      <p:grpSpPr>
+        <a:xfrm>
+          <a:off x="0" y="0"/>
+          <a:ext cx="0" cy="0"/>
+          <a:chOff x="0" y="0"/>
+          <a:chExt cx="0" cy="0"/>
+        </a:xfrm>
+      </p:grpSpPr>
+      <p:pic>
+        <p:nvPicPr>
+          <p:cNvPr id="7" name="圖片 6">
+            <a:extLst>
+              <a:ext uri="{FF2B5EF4-FFF2-40B4-BE49-F238E27FC236}">
+                <a16:creationId xmlns:a16="http://schemas.microsoft.com/office/drawing/2014/main" id="{D5A01124-C611-5166-0539-3AC761C67E8E}"/>
+              </a:ext>
+            </a:extLst>
+          </p:cNvPr>
+          <p:cNvPicPr>
+            <a:picLocks noChangeAspect="1"/>
+          </p:cNvPicPr>
+          <p:nvPr/>
+        </p:nvPicPr>
+        <p:blipFill>
+          <a:blip r:embed="rId2"/>
+          <a:stretch>
+            <a:fillRect/>
+          </a:stretch>
+        </p:blipFill>
+        <p:spPr>
+          <a:xfrm>
+            <a:off x="1831023" y="705696"/>
+            <a:ext cx="8392747" cy="6112900"/>
+          </a:xfrm>
+          <a:prstGeom prst="rect">
+            <a:avLst/>
+          </a:prstGeom>
+        </p:spPr>
+      </p:pic>
+      <p:grpSp>
+        <p:nvGrpSpPr>
+          <p:cNvPr id="8" name="群組 7">
+            <a:extLst>
+              <a:ext uri="{FF2B5EF4-FFF2-40B4-BE49-F238E27FC236}">
+                <a16:creationId xmlns:a16="http://schemas.microsoft.com/office/drawing/2014/main" id="{01E11A6B-360B-4DB3-53DA-130082631A6B}"/>
+              </a:ext>
+            </a:extLst>
+          </p:cNvPr>
+          <p:cNvGrpSpPr/>
+          <p:nvPr/>
+        </p:nvGrpSpPr>
+        <p:grpSpPr>
+          <a:xfrm>
+            <a:off x="4505325" y="262028"/>
+            <a:ext cx="2971800" cy="1076325"/>
+            <a:chOff x="4505325" y="466311"/>
+            <a:chExt cx="2971800" cy="1076325"/>
+          </a:xfrm>
+        </p:grpSpPr>
+        <p:pic>
+          <p:nvPicPr>
+            <p:cNvPr id="9" name="圖形 8">
+              <a:extLst>
+                <a:ext uri="{FF2B5EF4-FFF2-40B4-BE49-F238E27FC236}">
+                  <a16:creationId xmlns:a16="http://schemas.microsoft.com/office/drawing/2014/main" id="{146F4A2E-A2DC-362E-68E3-E75415B5AD7E}"/>
+                </a:ext>
+              </a:extLst>
+            </p:cNvPr>
+            <p:cNvPicPr>
+              <a:picLocks noChangeAspect="1"/>
+            </p:cNvPicPr>
+            <p:nvPr/>
+          </p:nvPicPr>
+          <p:blipFill>
+            <a:blip>
+              <a:extLst>
+                <a:ext uri="{96DAC541-7B7A-43D3-8B79-37D633B846F1}">
+                  <asvg:svgBlip xmlns:asvg="http://schemas.microsoft.com/office/drawing/2016/SVG/main" r:embed="rId3"/>
+                </a:ext>
+              </a:extLst>
+            </a:blip>
+            <a:stretch>
+              <a:fillRect/>
+            </a:stretch>
+          </p:blipFill>
+          <p:spPr>
+            <a:xfrm>
+              <a:off x="4505325" y="466311"/>
+              <a:ext cx="1076325" cy="1076325"/>
+            </a:xfrm>
+            <a:prstGeom prst="rect">
+              <a:avLst/>
+            </a:prstGeom>
+          </p:spPr>
+        </p:pic>
+        <p:pic>
+          <p:nvPicPr>
+            <p:cNvPr id="10" name="圖形 9">
+              <a:extLst>
+                <a:ext uri="{FF2B5EF4-FFF2-40B4-BE49-F238E27FC236}">
+                  <a16:creationId xmlns:a16="http://schemas.microsoft.com/office/drawing/2014/main" id="{DF912917-9EBC-1FB6-435C-FFF1374282F9}"/>
+                </a:ext>
+              </a:extLst>
+            </p:cNvPr>
+            <p:cNvPicPr>
+              <a:picLocks noChangeAspect="1"/>
+            </p:cNvPicPr>
+            <p:nvPr/>
+          </p:nvPicPr>
+          <p:blipFill>
+            <a:blip>
+              <a:extLst>
+                <a:ext uri="{96DAC541-7B7A-43D3-8B79-37D633B846F1}">
+                  <asvg:svgBlip xmlns:asvg="http://schemas.microsoft.com/office/drawing/2016/SVG/main" r:embed="rId3"/>
+                </a:ext>
+              </a:extLst>
+            </a:blip>
+            <a:stretch>
+              <a:fillRect/>
+            </a:stretch>
+          </p:blipFill>
+          <p:spPr>
+            <a:xfrm>
+              <a:off x="6400800" y="466311"/>
+              <a:ext cx="1076325" cy="1076325"/>
+            </a:xfrm>
+            <a:prstGeom prst="rect">
+              <a:avLst/>
+            </a:prstGeom>
+          </p:spPr>
+        </p:pic>
+      </p:grpSp>
+      <p:cxnSp>
+        <p:nvCxnSpPr>
+          <p:cNvPr id="19" name="直線接點 18">
+            <a:extLst>
+              <a:ext uri="{FF2B5EF4-FFF2-40B4-BE49-F238E27FC236}">
+                <a16:creationId xmlns:a16="http://schemas.microsoft.com/office/drawing/2014/main" id="{E6AE12CE-16D5-04CF-409A-4C52AF1E209E}"/>
+              </a:ext>
+            </a:extLst>
+          </p:cNvPr>
+          <p:cNvCxnSpPr/>
+          <p:nvPr/>
+        </p:nvCxnSpPr>
+        <p:spPr>
+          <a:xfrm>
+            <a:off x="5186317" y="1588653"/>
+            <a:ext cx="4179356" cy="0"/>
+          </a:xfrm>
+          <a:prstGeom prst="line">
+            <a:avLst/>
+          </a:prstGeom>
+          <a:ln w="76200">
+            <a:solidFill>
+              <a:srgbClr val="049434"/>
+            </a:solidFill>
+          </a:ln>
+        </p:spPr>
+        <p:style>
+          <a:lnRef idx="2">
+            <a:schemeClr val="accent1"/>
+          </a:lnRef>
+          <a:fillRef idx="0">
+            <a:schemeClr val="accent1"/>
+          </a:fillRef>
+          <a:effectRef idx="1">
+            <a:schemeClr val="accent1"/>
+          </a:effectRef>
+          <a:fontRef idx="minor">
+            <a:schemeClr val="tx1"/>
+          </a:fontRef>
+        </p:style>
+      </p:cxnSp>
+      <p:cxnSp>
+        <p:nvCxnSpPr>
+          <p:cNvPr id="3" name="直線接點 2">
+            <a:extLst>
+              <a:ext uri="{FF2B5EF4-FFF2-40B4-BE49-F238E27FC236}">
+                <a16:creationId xmlns:a16="http://schemas.microsoft.com/office/drawing/2014/main" id="{05708A91-25FA-55D8-4712-440F7E5429F9}"/>
+              </a:ext>
+            </a:extLst>
+          </p:cNvPr>
+          <p:cNvCxnSpPr/>
+          <p:nvPr/>
+        </p:nvCxnSpPr>
+        <p:spPr>
+          <a:xfrm>
+            <a:off x="7610764" y="1782618"/>
+            <a:ext cx="1505527" cy="0"/>
+          </a:xfrm>
+          <a:prstGeom prst="line">
+            <a:avLst/>
+          </a:prstGeom>
+          <a:ln w="76200"/>
+        </p:spPr>
+        <p:style>
+          <a:lnRef idx="2">
+            <a:schemeClr val="accent4"/>
+          </a:lnRef>
+          <a:fillRef idx="0">
+            <a:schemeClr val="accent4"/>
+          </a:fillRef>
+          <a:effectRef idx="1">
+            <a:schemeClr val="accent4"/>
+          </a:effectRef>
+          <a:fontRef idx="minor">
+            <a:schemeClr val="tx1"/>
+          </a:fontRef>
+        </p:style>
+      </p:cxnSp>
+      <p:cxnSp>
+        <p:nvCxnSpPr>
+          <p:cNvPr id="4" name="直線接點 3">
+            <a:extLst>
+              <a:ext uri="{FF2B5EF4-FFF2-40B4-BE49-F238E27FC236}">
+                <a16:creationId xmlns:a16="http://schemas.microsoft.com/office/drawing/2014/main" id="{C010FA95-64EE-5DFE-4AA2-7CAA316884B8}"/>
+              </a:ext>
+            </a:extLst>
+          </p:cNvPr>
+          <p:cNvCxnSpPr/>
+          <p:nvPr/>
+        </p:nvCxnSpPr>
+        <p:spPr>
+          <a:xfrm>
+            <a:off x="7610764" y="3514436"/>
+            <a:ext cx="1505527" cy="0"/>
+          </a:xfrm>
+          <a:prstGeom prst="line">
+            <a:avLst/>
+          </a:prstGeom>
+          <a:ln w="76200">
+            <a:solidFill>
+              <a:srgbClr val="002060"/>
+            </a:solidFill>
+          </a:ln>
+        </p:spPr>
+        <p:style>
+          <a:lnRef idx="2">
+            <a:schemeClr val="accent4"/>
+          </a:lnRef>
+          <a:fillRef idx="0">
+            <a:schemeClr val="accent4"/>
+          </a:fillRef>
+          <a:effectRef idx="1">
+            <a:schemeClr val="accent4"/>
+          </a:effectRef>
+          <a:fontRef idx="minor">
+            <a:schemeClr val="tx1"/>
+          </a:fontRef>
+        </p:style>
+      </p:cxnSp>
+      <p:cxnSp>
+        <p:nvCxnSpPr>
+          <p:cNvPr id="5" name="直線接點 4">
+            <a:extLst>
+              <a:ext uri="{FF2B5EF4-FFF2-40B4-BE49-F238E27FC236}">
+                <a16:creationId xmlns:a16="http://schemas.microsoft.com/office/drawing/2014/main" id="{5B180585-321A-EBA6-7D93-7CC4DEEE27CB}"/>
+              </a:ext>
+            </a:extLst>
+          </p:cNvPr>
+          <p:cNvCxnSpPr/>
+          <p:nvPr/>
+        </p:nvCxnSpPr>
+        <p:spPr>
+          <a:xfrm>
+            <a:off x="2999798" y="5749637"/>
+            <a:ext cx="1505527" cy="0"/>
+          </a:xfrm>
+          <a:prstGeom prst="line">
+            <a:avLst/>
+          </a:prstGeom>
+          <a:ln w="76200"/>
+        </p:spPr>
+        <p:style>
+          <a:lnRef idx="2">
+            <a:schemeClr val="accent4"/>
+          </a:lnRef>
+          <a:fillRef idx="0">
+            <a:schemeClr val="accent4"/>
+          </a:fillRef>
+          <a:effectRef idx="1">
+            <a:schemeClr val="accent4"/>
+          </a:effectRef>
+          <a:fontRef idx="minor">
+            <a:schemeClr val="tx1"/>
+          </a:fontRef>
+        </p:style>
+      </p:cxnSp>
+      <p:cxnSp>
+        <p:nvCxnSpPr>
+          <p:cNvPr id="6" name="直線接點 5">
+            <a:extLst>
+              <a:ext uri="{FF2B5EF4-FFF2-40B4-BE49-F238E27FC236}">
+                <a16:creationId xmlns:a16="http://schemas.microsoft.com/office/drawing/2014/main" id="{33E99434-9AAB-59F7-CA4C-6FAA4B28F248}"/>
+              </a:ext>
+            </a:extLst>
+          </p:cNvPr>
+          <p:cNvCxnSpPr/>
+          <p:nvPr/>
+        </p:nvCxnSpPr>
+        <p:spPr>
+          <a:xfrm>
+            <a:off x="2999798" y="4073236"/>
+            <a:ext cx="1505527" cy="0"/>
+          </a:xfrm>
+          <a:prstGeom prst="line">
+            <a:avLst/>
+          </a:prstGeom>
+          <a:ln w="76200">
+            <a:solidFill>
+              <a:srgbClr val="002060"/>
+            </a:solidFill>
+          </a:ln>
+        </p:spPr>
+        <p:style>
+          <a:lnRef idx="2">
+            <a:schemeClr val="accent4"/>
+          </a:lnRef>
+          <a:fillRef idx="0">
+            <a:schemeClr val="accent4"/>
+          </a:fillRef>
+          <a:effectRef idx="1">
+            <a:schemeClr val="accent4"/>
+          </a:effectRef>
+          <a:fontRef idx="minor">
+            <a:schemeClr val="tx1"/>
+          </a:fontRef>
+        </p:style>
+      </p:cxnSp>
+      <p:sp>
+        <p:nvSpPr>
+          <p:cNvPr id="25" name="手繪多邊形: 圖案 24">
+            <a:extLst>
+              <a:ext uri="{FF2B5EF4-FFF2-40B4-BE49-F238E27FC236}">
+                <a16:creationId xmlns:a16="http://schemas.microsoft.com/office/drawing/2014/main" id="{A5432C9D-9B21-B9B2-742F-C8BC1296F3FB}"/>
+              </a:ext>
+            </a:extLst>
+          </p:cNvPr>
+          <p:cNvSpPr/>
+          <p:nvPr/>
+        </p:nvSpPr>
+        <p:spPr>
+          <a:xfrm>
+            <a:off x="4525818" y="2004291"/>
+            <a:ext cx="3066473" cy="3431143"/>
+          </a:xfrm>
+          <a:custGeom>
+            <a:avLst/>
+            <a:gdLst>
+              <a:gd name="csX0" fmla="*/ 0 w 3066473"/>
+              <a:gd name="csY0" fmla="*/ 0 h 3431143"/>
+              <a:gd name="csX1" fmla="*/ 369455 w 3066473"/>
+              <a:gd name="csY1" fmla="*/ 277091 h 3431143"/>
+              <a:gd name="csX2" fmla="*/ 600364 w 3066473"/>
+              <a:gd name="csY2" fmla="*/ 1514764 h 3431143"/>
+              <a:gd name="csX3" fmla="*/ 692727 w 3066473"/>
+              <a:gd name="csY3" fmla="*/ 1764145 h 3431143"/>
+              <a:gd name="csX4" fmla="*/ 1514764 w 3066473"/>
+              <a:gd name="csY4" fmla="*/ 1773382 h 3431143"/>
+              <a:gd name="csX5" fmla="*/ 2216727 w 3066473"/>
+              <a:gd name="csY5" fmla="*/ 1773382 h 3431143"/>
+              <a:gd name="csX6" fmla="*/ 2484582 w 3066473"/>
+              <a:gd name="csY6" fmla="*/ 1948873 h 3431143"/>
+              <a:gd name="csX7" fmla="*/ 2697018 w 3066473"/>
+              <a:gd name="csY7" fmla="*/ 2530764 h 3431143"/>
+              <a:gd name="csX8" fmla="*/ 2927927 w 3066473"/>
+              <a:gd name="csY8" fmla="*/ 3315854 h 3431143"/>
+              <a:gd name="csX9" fmla="*/ 3066473 w 3066473"/>
+              <a:gd name="csY9" fmla="*/ 3426691 h 3431143"/>
+              <a:gd name="csX10" fmla="*/ 3066473 w 3066473"/>
+              <a:gd name="csY10" fmla="*/ 3426691 h 3431143"/>
+              <a:gd name="csX11" fmla="*/ 3066473 w 3066473"/>
+              <a:gd name="csY11" fmla="*/ 3426691 h 3431143"/>
+              <a:gd name="csX0" fmla="*/ 0 w 3066473"/>
+              <a:gd name="csY0" fmla="*/ 0 h 3431143"/>
+              <a:gd name="csX1" fmla="*/ 369455 w 3066473"/>
+              <a:gd name="csY1" fmla="*/ 277091 h 3431143"/>
+              <a:gd name="csX2" fmla="*/ 600364 w 3066473"/>
+              <a:gd name="csY2" fmla="*/ 1514764 h 3431143"/>
+              <a:gd name="csX3" fmla="*/ 905163 w 3066473"/>
+              <a:gd name="csY3" fmla="*/ 1819563 h 3431143"/>
+              <a:gd name="csX4" fmla="*/ 1514764 w 3066473"/>
+              <a:gd name="csY4" fmla="*/ 1773382 h 3431143"/>
+              <a:gd name="csX5" fmla="*/ 2216727 w 3066473"/>
+              <a:gd name="csY5" fmla="*/ 1773382 h 3431143"/>
+              <a:gd name="csX6" fmla="*/ 2484582 w 3066473"/>
+              <a:gd name="csY6" fmla="*/ 1948873 h 3431143"/>
+              <a:gd name="csX7" fmla="*/ 2697018 w 3066473"/>
+              <a:gd name="csY7" fmla="*/ 2530764 h 3431143"/>
+              <a:gd name="csX8" fmla="*/ 2927927 w 3066473"/>
+              <a:gd name="csY8" fmla="*/ 3315854 h 3431143"/>
+              <a:gd name="csX9" fmla="*/ 3066473 w 3066473"/>
+              <a:gd name="csY9" fmla="*/ 3426691 h 3431143"/>
+              <a:gd name="csX10" fmla="*/ 3066473 w 3066473"/>
+              <a:gd name="csY10" fmla="*/ 3426691 h 3431143"/>
+              <a:gd name="csX11" fmla="*/ 3066473 w 3066473"/>
+              <a:gd name="csY11" fmla="*/ 3426691 h 3431143"/>
+              <a:gd name="csX0" fmla="*/ 0 w 3066473"/>
+              <a:gd name="csY0" fmla="*/ 0 h 3431143"/>
+              <a:gd name="csX1" fmla="*/ 369455 w 3066473"/>
+              <a:gd name="csY1" fmla="*/ 277091 h 3431143"/>
+              <a:gd name="csX2" fmla="*/ 600364 w 3066473"/>
+              <a:gd name="csY2" fmla="*/ 1514764 h 3431143"/>
+              <a:gd name="csX3" fmla="*/ 905163 w 3066473"/>
+              <a:gd name="csY3" fmla="*/ 1819563 h 3431143"/>
+              <a:gd name="csX4" fmla="*/ 1514764 w 3066473"/>
+              <a:gd name="csY4" fmla="*/ 1773382 h 3431143"/>
+              <a:gd name="csX5" fmla="*/ 2216727 w 3066473"/>
+              <a:gd name="csY5" fmla="*/ 1773382 h 3431143"/>
+              <a:gd name="csX6" fmla="*/ 2484582 w 3066473"/>
+              <a:gd name="csY6" fmla="*/ 1948873 h 3431143"/>
+              <a:gd name="csX7" fmla="*/ 2697018 w 3066473"/>
+              <a:gd name="csY7" fmla="*/ 2530764 h 3431143"/>
+              <a:gd name="csX8" fmla="*/ 2927927 w 3066473"/>
+              <a:gd name="csY8" fmla="*/ 3315854 h 3431143"/>
+              <a:gd name="csX9" fmla="*/ 3066473 w 3066473"/>
+              <a:gd name="csY9" fmla="*/ 3426691 h 3431143"/>
+              <a:gd name="csX10" fmla="*/ 3066473 w 3066473"/>
+              <a:gd name="csY10" fmla="*/ 3426691 h 3431143"/>
+              <a:gd name="csX11" fmla="*/ 3066473 w 3066473"/>
+              <a:gd name="csY11" fmla="*/ 3426691 h 3431143"/>
+            </a:gdLst>
+            <a:ahLst/>
+            <a:cxnLst>
+              <a:cxn ang="0">
+                <a:pos x="csX0" y="csY0"/>
+              </a:cxn>
+              <a:cxn ang="0">
+                <a:pos x="csX1" y="csY1"/>
+              </a:cxn>
+              <a:cxn ang="0">
+                <a:pos x="csX2" y="csY2"/>
+              </a:cxn>
+              <a:cxn ang="0">
+                <a:pos x="csX3" y="csY3"/>
+              </a:cxn>
+              <a:cxn ang="0">
+                <a:pos x="csX4" y="csY4"/>
+              </a:cxn>
+              <a:cxn ang="0">
+                <a:pos x="csX5" y="csY5"/>
+              </a:cxn>
+              <a:cxn ang="0">
+                <a:pos x="csX6" y="csY6"/>
+              </a:cxn>
+              <a:cxn ang="0">
+                <a:pos x="csX7" y="csY7"/>
+              </a:cxn>
+              <a:cxn ang="0">
+                <a:pos x="csX8" y="csY8"/>
+              </a:cxn>
+              <a:cxn ang="0">
+                <a:pos x="csX9" y="csY9"/>
+              </a:cxn>
+              <a:cxn ang="0">
+                <a:pos x="csX10" y="csY10"/>
+              </a:cxn>
+              <a:cxn ang="0">
+                <a:pos x="csX11" y="csY11"/>
+              </a:cxn>
+            </a:cxnLst>
+            <a:rect l="l" t="t" r="r" b="b"/>
+            <a:pathLst>
+              <a:path w="3066473" h="3431143">
+                <a:moveTo>
+                  <a:pt x="0" y="0"/>
+                </a:moveTo>
+                <a:cubicBezTo>
+                  <a:pt x="134697" y="12315"/>
+                  <a:pt x="269394" y="24630"/>
+                  <a:pt x="369455" y="277091"/>
+                </a:cubicBezTo>
+                <a:cubicBezTo>
+                  <a:pt x="469516" y="529552"/>
+                  <a:pt x="511079" y="1257685"/>
+                  <a:pt x="600364" y="1514764"/>
+                </a:cubicBezTo>
+                <a:cubicBezTo>
+                  <a:pt x="689649" y="1771843"/>
+                  <a:pt x="771236" y="1785696"/>
+                  <a:pt x="905163" y="1819563"/>
+                </a:cubicBezTo>
+                <a:cubicBezTo>
+                  <a:pt x="1039090" y="1853430"/>
+                  <a:pt x="1296170" y="1781079"/>
+                  <a:pt x="1514764" y="1773382"/>
+                </a:cubicBezTo>
+                <a:cubicBezTo>
+                  <a:pt x="1733358" y="1765685"/>
+                  <a:pt x="2055091" y="1744133"/>
+                  <a:pt x="2216727" y="1773382"/>
+                </a:cubicBezTo>
+                <a:cubicBezTo>
+                  <a:pt x="2378363" y="1802631"/>
+                  <a:pt x="2404534" y="1822643"/>
+                  <a:pt x="2484582" y="1948873"/>
+                </a:cubicBezTo>
+                <a:cubicBezTo>
+                  <a:pt x="2564630" y="2075103"/>
+                  <a:pt x="2623127" y="2302934"/>
+                  <a:pt x="2697018" y="2530764"/>
+                </a:cubicBezTo>
+                <a:cubicBezTo>
+                  <a:pt x="2770909" y="2758594"/>
+                  <a:pt x="2866351" y="3166533"/>
+                  <a:pt x="2927927" y="3315854"/>
+                </a:cubicBezTo>
+                <a:cubicBezTo>
+                  <a:pt x="2989503" y="3465175"/>
+                  <a:pt x="3066473" y="3426691"/>
+                  <a:pt x="3066473" y="3426691"/>
+                </a:cubicBezTo>
+                <a:lnTo>
+                  <a:pt x="3066473" y="3426691"/>
+                </a:lnTo>
+                <a:lnTo>
+                  <a:pt x="3066473" y="3426691"/>
+                </a:lnTo>
+              </a:path>
+            </a:pathLst>
+          </a:custGeom>
+          <a:noFill/>
+          <a:ln w="76200"/>
+        </p:spPr>
+        <p:style>
+          <a:lnRef idx="2">
+            <a:schemeClr val="accent1">
+              <a:shade val="15000"/>
+            </a:schemeClr>
+          </a:lnRef>
+          <a:fillRef idx="1">
+            <a:schemeClr val="accent1"/>
+          </a:fillRef>
+          <a:effectRef idx="0">
+            <a:schemeClr val="accent1"/>
+          </a:effectRef>
+          <a:fontRef idx="minor">
+            <a:schemeClr val="lt1"/>
+          </a:fontRef>
+        </p:style>
+        <p:txBody>
+          <a:bodyPr rtlCol="0" anchor="ctr"/>
+          <a:lstStyle/>
+          <a:p>
+            <a:pPr algn="ctr"/>
+            <a:endParaRPr lang="zh-TW" altLang="en-US" dirty="0"/>
+          </a:p>
+        </p:txBody>
+      </p:sp>
+    </p:spTree>
+    <p:extLst>
+      <p:ext uri="{BB962C8B-B14F-4D97-AF65-F5344CB8AC3E}">
+        <p14:creationId xmlns:p14="http://schemas.microsoft.com/office/powerpoint/2010/main" val="779573481"/>
+      </p:ext>
+    </p:extLst>
+  </p:cSld>
+  <p:clrMapOvr>
+    <a:masterClrMapping/>
+  </p:clrMapOvr>
+  <p:timing>
+    <p:tnLst>
+      <p:par>
+        <p:cTn id="1" dur="indefinite" restart="never" nodeType="tmRoot">
+          <p:childTnLst>
+            <p:seq concurrent="1" nextAc="seek">
+              <p:cTn id="2" dur="indefinite" nodeType="mainSeq">
+                <p:childTnLst>
+                  <p:par>
+                    <p:cTn id="3" fill="hold">
+                      <p:stCondLst>
+                        <p:cond delay="indefinite"/>
+                      </p:stCondLst>
+                      <p:childTnLst>
+                        <p:par>
+                          <p:cTn id="4" fill="hold">
+                            <p:stCondLst>
+                              <p:cond delay="0"/>
+                            </p:stCondLst>
+                            <p:childTnLst>
+                              <p:par>
+                                <p:cTn id="5" presetID="1" presetClass="entr" presetSubtype="0" fill="hold" nodeType="clickEffect">
+                                  <p:stCondLst>
+                                    <p:cond delay="0"/>
+                                  </p:stCondLst>
+                                  <p:childTnLst>
+                                    <p:set>
+                                      <p:cBhvr>
+                                        <p:cTn id="6" dur="1" fill="hold">
+                                          <p:stCondLst>
+                                            <p:cond delay="0"/>
+                                          </p:stCondLst>
+                                        </p:cTn>
+                                        <p:tgtEl>
+                                          <p:spTgt spid="19"/>
+                                        </p:tgtEl>
+                                        <p:attrNameLst>
+                                          <p:attrName>style.visibility</p:attrName>
+                                        </p:attrNameLst>
+                                      </p:cBhvr>
+                                      <p:to>
+                                        <p:strVal val="visible"/>
+                                      </p:to>
+                                    </p:set>
+                                  </p:childTnLst>
+                                </p:cTn>
+                              </p:par>
+                            </p:childTnLst>
+                          </p:cTn>
+                        </p:par>
+                        <p:par>
+                          <p:cTn id="7" fill="hold">
+                            <p:stCondLst>
+                              <p:cond delay="0"/>
+                            </p:stCondLst>
+                            <p:childTnLst>
+                              <p:par>
+                                <p:cTn id="8" presetID="42" presetClass="path" presetSubtype="0" accel="50000" decel="50000" fill="hold" nodeType="afterEffect">
+                                  <p:stCondLst>
+                                    <p:cond delay="0"/>
+                                  </p:stCondLst>
+                                  <p:childTnLst>
+                                    <p:animMotion origin="layout" path="M 0 0 L 0 0.25 E" pathEditMode="relative" ptsTypes="">
+                                      <p:cBhvr>
+                                        <p:cTn id="9" dur="2000" fill="hold"/>
+                                        <p:tgtEl>
+                                          <p:spTgt spid="3"/>
+                                        </p:tgtEl>
+                                        <p:attrNameLst>
+                                          <p:attrName>ppt_x</p:attrName>
+                                          <p:attrName>ppt_y</p:attrName>
+                                        </p:attrNameLst>
+                                      </p:cBhvr>
+                                    </p:animMotion>
+                                  </p:childTnLst>
+                                </p:cTn>
+                              </p:par>
+                              <p:par>
+                                <p:cTn id="10" presetID="42" presetClass="path" presetSubtype="0" accel="50000" decel="50000" fill="hold" nodeType="withEffect">
+                                  <p:stCondLst>
+                                    <p:cond delay="0"/>
+                                  </p:stCondLst>
+                                  <p:childTnLst>
+                                    <p:animMotion origin="layout" path="M -2.5E-6 4.07407E-6 L -8.33333E-7 -0.24445 " pathEditMode="relative" rAng="0" ptsTypes="AA">
+                                      <p:cBhvr>
+                                        <p:cTn id="11" dur="2000" fill="hold"/>
+                                        <p:tgtEl>
+                                          <p:spTgt spid="5"/>
+                                        </p:tgtEl>
+                                        <p:attrNameLst>
+                                          <p:attrName>ppt_x</p:attrName>
+                                          <p:attrName>ppt_y</p:attrName>
+                                        </p:attrNameLst>
+                                      </p:cBhvr>
+                                      <p:rCtr x="-52" y="-12222"/>
+                                    </p:animMotion>
+                                  </p:childTnLst>
+                                </p:cTn>
+                              </p:par>
+                            </p:childTnLst>
+                          </p:cTn>
+                        </p:par>
+                      </p:childTnLst>
+                    </p:cTn>
+                  </p:par>
+                  <p:par>
+                    <p:cTn id="12" fill="hold">
+                      <p:stCondLst>
+                        <p:cond delay="indefinite"/>
+                      </p:stCondLst>
+                      <p:childTnLst>
+                        <p:par>
+                          <p:cTn id="13" fill="hold">
+                            <p:stCondLst>
+                              <p:cond delay="0"/>
+                            </p:stCondLst>
+                            <p:childTnLst>
+                              <p:par>
+                                <p:cTn id="14" presetID="1" presetClass="entr" presetSubtype="0" fill="hold" nodeType="clickEffect">
+                                  <p:stCondLst>
+                                    <p:cond delay="0"/>
+                                  </p:stCondLst>
+                                  <p:childTnLst>
+                                    <p:set>
+                                      <p:cBhvr>
+                                        <p:cTn id="15" dur="1" fill="hold">
+                                          <p:stCondLst>
+                                            <p:cond delay="0"/>
+                                          </p:stCondLst>
+                                        </p:cTn>
+                                        <p:tgtEl>
+                                          <p:spTgt spid="4"/>
+                                        </p:tgtEl>
+                                        <p:attrNameLst>
+                                          <p:attrName>style.visibility</p:attrName>
+                                        </p:attrNameLst>
+                                      </p:cBhvr>
+                                      <p:to>
+                                        <p:strVal val="visible"/>
+                                      </p:to>
+                                    </p:set>
+                                  </p:childTnLst>
+                                </p:cTn>
+                              </p:par>
+                            </p:childTnLst>
+                          </p:cTn>
+                        </p:par>
+                        <p:par>
+                          <p:cTn id="16" fill="hold">
+                            <p:stCondLst>
+                              <p:cond delay="0"/>
+                            </p:stCondLst>
+                            <p:childTnLst>
+                              <p:par>
+                                <p:cTn id="17" presetID="42" presetClass="path" presetSubtype="0" accel="50000" decel="50000" fill="hold" nodeType="afterEffect">
+                                  <p:stCondLst>
+                                    <p:cond delay="100"/>
+                                  </p:stCondLst>
+                                  <p:childTnLst>
+                                    <p:animMotion origin="layout" path="M 2.5E-6 -1.11022E-16 L -0.00039 0.28218 " pathEditMode="relative" rAng="0" ptsTypes="AA">
+                                      <p:cBhvr>
+                                        <p:cTn id="18" dur="2000" fill="hold"/>
+                                        <p:tgtEl>
+                                          <p:spTgt spid="4"/>
+                                        </p:tgtEl>
+                                        <p:attrNameLst>
+                                          <p:attrName>ppt_x</p:attrName>
+                                          <p:attrName>ppt_y</p:attrName>
+                                        </p:attrNameLst>
+                                      </p:cBhvr>
+                                      <p:rCtr x="-26" y="14097"/>
+                                    </p:animMotion>
+                                  </p:childTnLst>
+                                </p:cTn>
+                              </p:par>
+                              <p:par>
+                                <p:cTn id="19" presetID="1" presetClass="entr" presetSubtype="0" fill="hold" nodeType="withEffect">
+                                  <p:stCondLst>
+                                    <p:cond delay="0"/>
+                                  </p:stCondLst>
+                                  <p:childTnLst>
+                                    <p:set>
+                                      <p:cBhvr>
+                                        <p:cTn id="20" dur="1" fill="hold">
+                                          <p:stCondLst>
+                                            <p:cond delay="0"/>
+                                          </p:stCondLst>
+                                        </p:cTn>
+                                        <p:tgtEl>
+                                          <p:spTgt spid="6"/>
+                                        </p:tgtEl>
+                                        <p:attrNameLst>
+                                          <p:attrName>style.visibility</p:attrName>
+                                        </p:attrNameLst>
+                                      </p:cBhvr>
+                                      <p:to>
+                                        <p:strVal val="visible"/>
+                                      </p:to>
+                                    </p:set>
+                                  </p:childTnLst>
+                                </p:cTn>
+                              </p:par>
+                              <p:par>
+                                <p:cTn id="21" presetID="42" presetClass="path" presetSubtype="0" accel="50000" decel="50000" fill="hold" nodeType="withEffect">
+                                  <p:stCondLst>
+                                    <p:cond delay="0"/>
+                                  </p:stCondLst>
+                                  <p:childTnLst>
+                                    <p:animMotion origin="layout" path="M -2.5E-6 -1.48148E-6 L 0.0013 -0.30162 " pathEditMode="relative" rAng="0" ptsTypes="AA">
+                                      <p:cBhvr>
+                                        <p:cTn id="22" dur="2000" fill="hold"/>
+                                        <p:tgtEl>
+                                          <p:spTgt spid="6"/>
+                                        </p:tgtEl>
+                                        <p:attrNameLst>
+                                          <p:attrName>ppt_x</p:attrName>
+                                          <p:attrName>ppt_y</p:attrName>
+                                        </p:attrNameLst>
+                                      </p:cBhvr>
+                                      <p:rCtr x="65" y="-15093"/>
+                                    </p:animMotion>
+                                  </p:childTnLst>
+                                </p:cTn>
+                              </p:par>
+                            </p:childTnLst>
+                          </p:cTn>
+                        </p:par>
+                        <p:par>
+                          <p:cTn id="23" fill="hold">
+                            <p:stCondLst>
+                              <p:cond delay="2100"/>
+                            </p:stCondLst>
+                            <p:childTnLst>
+                              <p:par>
+                                <p:cTn id="24" presetID="1" presetClass="entr" presetSubtype="0" fill="hold" grpId="0" nodeType="afterEffect">
+                                  <p:stCondLst>
+                                    <p:cond delay="0"/>
+                                  </p:stCondLst>
+                                  <p:childTnLst>
+                                    <p:set>
+                                      <p:cBhvr>
+                                        <p:cTn id="25" dur="1" fill="hold">
+                                          <p:stCondLst>
+                                            <p:cond delay="0"/>
+                                          </p:stCondLst>
+                                        </p:cTn>
+                                        <p:tgtEl>
+                                          <p:spTgt spid="25"/>
+                                        </p:tgtEl>
+                                        <p:attrNameLst>
+                                          <p:attrName>style.visibility</p:attrName>
+                                        </p:attrNameLst>
+                                      </p:cBhvr>
+                                      <p:to>
+                                        <p:strVal val="visible"/>
+                                      </p:to>
+                                    </p:set>
+                                  </p:childTnLst>
+                                </p:cTn>
+                              </p:par>
+                            </p:childTnLst>
+                          </p:cTn>
+                        </p:par>
+                      </p:childTnLst>
+                    </p:cTn>
+                  </p:par>
+                </p:childTnLst>
+              </p:cTn>
+              <p:prevCondLst>
+                <p:cond evt="onPrev" delay="0">
+                  <p:tgtEl>
+                    <p:sldTgt/>
+                  </p:tgtEl>
+                </p:cond>
+              </p:prevCondLst>
+              <p:nextCondLst>
+                <p:cond evt="onNext" delay="0">
+                  <p:tgtEl>
+                    <p:sldTgt/>
+                  </p:tgtEl>
+                </p:cond>
+              </p:nextCondLst>
+            </p:seq>
+          </p:childTnLst>
+        </p:cTn>
+      </p:par>
+    </p:tnLst>
+    <p:bldLst>
+      <p:bldP spid="25" grpId="0" animBg="1"/>
+    </p:bldLst>
+  </p:timing>
+</p:sld>
+</file>
+
+<file path=ppt/slides/slide9.xml><?xml version="1.0" encoding="utf-8"?>
+<p:sld xmlns:a="http://schemas.openxmlformats.org/drawingml/2006/main" xmlns:r="http://schemas.openxmlformats.org/officeDocument/2006/relationships" xmlns:p="http://schemas.openxmlformats.org/presentationml/2006/main">
+  <p:cSld>
+    <p:spTree>
+      <p:nvGrpSpPr>
+        <p:cNvPr id="1" name=""/>
+        <p:cNvGrpSpPr/>
+        <p:nvPr/>
+      </p:nvGrpSpPr>
+      <p:grpSpPr>
+        <a:xfrm>
+          <a:off x="0" y="0"/>
+          <a:ext cx="0" cy="0"/>
+          <a:chOff x="0" y="0"/>
+          <a:chExt cx="0" cy="0"/>
+        </a:xfrm>
+      </p:grpSpPr>
+      <p:pic>
+        <p:nvPicPr>
+          <p:cNvPr id="5" name="圖片 4">
+            <a:extLst>
+              <a:ext uri="{FF2B5EF4-FFF2-40B4-BE49-F238E27FC236}">
+                <a16:creationId xmlns:a16="http://schemas.microsoft.com/office/drawing/2014/main" id="{585EA3A8-789A-B9CC-B4C1-880969259A4F}"/>
+              </a:ext>
+            </a:extLst>
+          </p:cNvPr>
+          <p:cNvPicPr>
+            <a:picLocks noChangeAspect="1"/>
+          </p:cNvPicPr>
+          <p:nvPr/>
+        </p:nvPicPr>
+        <p:blipFill>
+          <a:blip r:embed="rId2"/>
+          <a:stretch>
+            <a:fillRect/>
+          </a:stretch>
+        </p:blipFill>
+        <p:spPr>
+          <a:xfrm>
+            <a:off x="2235770" y="1311559"/>
+            <a:ext cx="7198187" cy="4971789"/>
+          </a:xfrm>
+          <a:prstGeom prst="rect">
+            <a:avLst/>
+          </a:prstGeom>
+        </p:spPr>
+      </p:pic>
+    </p:spTree>
+    <p:extLst>
+      <p:ext uri="{BB962C8B-B14F-4D97-AF65-F5344CB8AC3E}">
+        <p14:creationId xmlns:p14="http://schemas.microsoft.com/office/powerpoint/2010/main" val="3917660026"/>
       </p:ext>
     </p:extLst>
   </p:cSld>

</xml_diff>